<commit_message>
Lesson sd-10-011: match the deck and its PPTX to the rewritten lesson
Co-Authored-By: Claude Sonnet 5.5 <noreply@anthropic.com>
Claude-Session: https://claude.ai/code/session_01Y9NYFwg4CcDYEWi1zr53gi
</commit_message>
<xml_diff>
--- a/system-design-101/vi/lessons/sd-10-011/slides/sd-10-011.pptx
+++ b/system-design-101/vi/lessons/sd-10-011/slides/sd-10-011.pptx
@@ -7709,15 +7709,37 @@
               <a:buNone/>
             </a:pPr>
             <a:r>
-              <a:rPr lang="en-US" sz="2850" dirty="0" spc="-4" kern="0">
-                <a:solidFill>
-                  <a:srgbClr val="14161C"/>
-                </a:solidFill>
-                <a:latin typeface="Be Vietnam Pro" pitchFamily="34" charset="0"/>
-                <a:ea typeface="Be Vietnam Pro" pitchFamily="34" charset="-122"/>
-                <a:cs typeface="Be Vietnam Pro" pitchFamily="34" charset="-120"/>
-              </a:rPr>
-              <a:t>Bộ</a:t>
+              <a:rPr lang="en-US" sz="2850" dirty="0" spc="-26" kern="0">
+                <a:solidFill>
+                  <a:srgbClr val="14161C"/>
+                </a:solidFill>
+                <a:latin typeface="Be Vietnam Pro" pitchFamily="34" charset="0"/>
+                <a:ea typeface="Be Vietnam Pro" pitchFamily="34" charset="-122"/>
+                <a:cs typeface="Be Vietnam Pro" pitchFamily="34" charset="-120"/>
+              </a:rPr>
+              <a:t>Intel</a:t>
+            </a:r>
+            <a:r>
+              <a:rPr lang="en-US" sz="2850" dirty="0" spc="2" kern="0">
+                <a:solidFill>
+                  <a:srgbClr val="14161C"/>
+                </a:solidFill>
+                <a:latin typeface="Be Vietnam Pro" pitchFamily="34" charset="0"/>
+                <a:ea typeface="Be Vietnam Pro" pitchFamily="34" charset="-122"/>
+                <a:cs typeface="Be Vietnam Pro" pitchFamily="34" charset="-120"/>
+              </a:rPr>
+              <a:t> x86,</a:t>
+            </a:r>
+            <a:r>
+              <a:rPr lang="en-US" sz="2850" dirty="0" spc="1" kern="0">
+                <a:solidFill>
+                  <a:srgbClr val="14161C"/>
+                </a:solidFill>
+                <a:latin typeface="Be Vietnam Pro" pitchFamily="34" charset="0"/>
+                <a:ea typeface="Be Vietnam Pro" pitchFamily="34" charset="-122"/>
+                <a:cs typeface="Be Vietnam Pro" pitchFamily="34" charset="-120"/>
+              </a:rPr>
+              <a:t> AMD64,</a:t>
             </a:r>
             <a:r>
               <a:rPr lang="en-US" sz="2850" dirty="0" spc="3" kern="0">
@@ -7728,40 +7750,7 @@
                 <a:ea typeface="Be Vietnam Pro" pitchFamily="34" charset="-122"/>
                 <a:cs typeface="Be Vietnam Pro" pitchFamily="34" charset="-120"/>
               </a:rPr>
-              <a:t> xử</a:t>
-            </a:r>
-            <a:r>
-              <a:rPr lang="en-US" sz="2850" dirty="0" spc="2" kern="0">
-                <a:solidFill>
-                  <a:srgbClr val="14161C"/>
-                </a:solidFill>
-                <a:latin typeface="Be Vietnam Pro" pitchFamily="34" charset="0"/>
-                <a:ea typeface="Be Vietnam Pro" pitchFamily="34" charset="-122"/>
-                <a:cs typeface="Be Vietnam Pro" pitchFamily="34" charset="-120"/>
-              </a:rPr>
-              <a:t> lý</a:t>
-            </a:r>
-            <a:r>
-              <a:rPr lang="en-US" sz="2850" dirty="0" spc="-21" kern="0">
-                <a:solidFill>
-                  <a:srgbClr val="14161C"/>
-                </a:solidFill>
-                <a:latin typeface="Be Vietnam Pro" pitchFamily="34" charset="0"/>
-                <a:ea typeface="Be Vietnam Pro" pitchFamily="34" charset="-122"/>
-                <a:cs typeface="Be Vietnam Pro" pitchFamily="34" charset="-120"/>
-              </a:rPr>
-              <a:t> Intel</a:t>
-            </a:r>
-            <a:r>
-              <a:rPr lang="en-US" sz="2850" dirty="0" spc="2" kern="0">
-                <a:solidFill>
-                  <a:srgbClr val="14161C"/>
-                </a:solidFill>
-                <a:latin typeface="Be Vietnam Pro" pitchFamily="34" charset="0"/>
-                <a:ea typeface="Be Vietnam Pro" pitchFamily="34" charset="-122"/>
-                <a:cs typeface="Be Vietnam Pro" pitchFamily="34" charset="-120"/>
-              </a:rPr>
-              <a:t> x86</a:t>
+              <a:t> M1</a:t>
             </a:r>
             <a:r>
               <a:rPr lang="en-US" sz="2850" dirty="0" spc="-2" kern="0">
@@ -7772,10 +7761,21 @@
                 <a:ea typeface="Be Vietnam Pro" pitchFamily="34" charset="-122"/>
                 <a:cs typeface="Be Vietnam Pro" pitchFamily="34" charset="-120"/>
               </a:rPr>
-              <a:t> dùng thứ</a:t>
-            </a:r>
-            <a:r>
-              <a:rPr lang="en-US" sz="2850" dirty="0" spc="0" kern="0">
+              <a:t> dùng</a:t>
+            </a:r>
+            <a:r>
+              <a:rPr lang="en-US" sz="2850" dirty="0" spc="-1" kern="0">
+                <a:solidFill>
+                  <a:srgbClr val="14161C"/>
+                </a:solidFill>
+                <a:latin typeface="Be Vietnam Pro" pitchFamily="34" charset="0"/>
+                <a:ea typeface="Be Vietnam Pro" pitchFamily="34" charset="-122"/>
+                <a:cs typeface="Be Vietnam Pro" pitchFamily="34" charset="-120"/>
+              </a:rPr>
+              <a:t> thứ</a:t>
+            </a:r>
+            <a:r>
+              <a:rPr lang="en-US" sz="2850" dirty="0" spc="-2" kern="0">
                 <a:solidFill>
                   <a:srgbClr val="14161C"/>
                 </a:solidFill>
@@ -9634,15 +9634,26 @@
               <a:buNone/>
             </a:pPr>
             <a:r>
-              <a:rPr lang="en-US" sz="2250" b="1" dirty="0" spc="-22" kern="0">
-                <a:solidFill>
-                  <a:srgbClr val="14161C"/>
-                </a:solidFill>
-                <a:latin typeface="Be Vietnam Pro" pitchFamily="34" charset="0"/>
-                <a:ea typeface="Be Vietnam Pro" pitchFamily="34" charset="-122"/>
-                <a:cs typeface="Be Vietnam Pro" pitchFamily="34" charset="-120"/>
-              </a:rPr>
-              <a:t>PowerPC</a:t>
+              <a:rPr lang="en-US" sz="2250" b="1" dirty="0" spc="-1" kern="0">
+                <a:solidFill>
+                  <a:srgbClr val="14161C"/>
+                </a:solidFill>
+                <a:latin typeface="Be Vietnam Pro" pitchFamily="34" charset="0"/>
+                <a:ea typeface="Be Vietnam Pro" pitchFamily="34" charset="-122"/>
+                <a:cs typeface="Be Vietnam Pro" pitchFamily="34" charset="-120"/>
+              </a:rPr>
+              <a:t>IBM</a:t>
+            </a:r>
+            <a:r>
+              <a:rPr lang="en-US" sz="2250" b="1" dirty="0" spc="0" kern="0">
+                <a:solidFill>
+                  <a:srgbClr val="14161C"/>
+                </a:solidFill>
+                <a:latin typeface="Be Vietnam Pro" pitchFamily="34" charset="0"/>
+                <a:ea typeface="Be Vietnam Pro" pitchFamily="34" charset="-122"/>
+                <a:cs typeface="Be Vietnam Pro" pitchFamily="34" charset="-120"/>
+              </a:rPr>
+              <a:t> z</a:t>
             </a:r>
             <a:r>
               <a:rPr lang="en-US" sz="2250" b="1" dirty="0" spc="-16" kern="0">
@@ -9656,17 +9667,6 @@
               <a:t> và</a:t>
             </a:r>
             <a:r>
-              <a:rPr lang="en-US" sz="2250" b="1" dirty="0" spc="-12" kern="0">
-                <a:solidFill>
-                  <a:srgbClr val="14161C"/>
-                </a:solidFill>
-                <a:latin typeface="Be Vietnam Pro" pitchFamily="34" charset="0"/>
-                <a:ea typeface="Be Vietnam Pro" pitchFamily="34" charset="-122"/>
-                <a:cs typeface="Be Vietnam Pro" pitchFamily="34" charset="-120"/>
-              </a:rPr>
-              <a:t> Motorola</a:t>
-            </a:r>
-            <a:r>
               <a:rPr lang="en-US" sz="2250" b="1" dirty="0" spc="2" kern="0">
                 <a:solidFill>
                   <a:srgbClr val="14161C"/>
@@ -9675,18 +9675,29 @@
                 <a:ea typeface="Be Vietnam Pro" pitchFamily="34" charset="-122"/>
                 <a:cs typeface="Be Vietnam Pro" pitchFamily="34" charset="-120"/>
               </a:rPr>
-              <a:t> 68k</a:t>
-            </a:r>
-            <a:r>
-              <a:rPr lang="en-US" sz="2250" b="1" dirty="0" spc="13" kern="0">
-                <a:solidFill>
-                  <a:srgbClr val="14161C"/>
-                </a:solidFill>
-                <a:latin typeface="Be Vietnam Pro" pitchFamily="34" charset="0"/>
-                <a:ea typeface="Be Vietnam Pro" pitchFamily="34" charset="-122"/>
-                <a:cs typeface="Be Vietnam Pro" pitchFamily="34" charset="-120"/>
-              </a:rPr>
-              <a:t> đời</a:t>
+              <a:t> nhiều</a:t>
+            </a:r>
+            <a:r>
+              <a:rPr lang="en-US" sz="2250" b="1" dirty="0" spc="-2" kern="0">
+                <a:solidFill>
+                  <a:srgbClr val="14161C"/>
+                </a:solidFill>
+                <a:latin typeface="Be Vietnam Pro" pitchFamily="34" charset="0"/>
+                <a:ea typeface="Be Vietnam Pro" pitchFamily="34" charset="-122"/>
+                <a:cs typeface="Be Vietnam Pro" pitchFamily="34" charset="-120"/>
+              </a:rPr>
+              <a:t> kiến</a:t>
+            </a:r>
+            <a:r>
+              <a:rPr lang="en-US" sz="2250" b="1" dirty="0" spc="2" kern="0">
+                <a:solidFill>
+                  <a:srgbClr val="14161C"/>
+                </a:solidFill>
+                <a:latin typeface="Be Vietnam Pro" pitchFamily="34" charset="0"/>
+                <a:ea typeface="Be Vietnam Pro" pitchFamily="34" charset="-122"/>
+                <a:cs typeface="Be Vietnam Pro" pitchFamily="34" charset="-120"/>
+              </a:rPr>
+              <a:t> trúc</a:t>
             </a:r>
             <a:r>
               <a:rPr lang="en-US" sz="2250" b="1" dirty="0" spc="3" kern="0">
@@ -9737,7 +9748,7 @@
               <a:buNone/>
             </a:pPr>
             <a:r>
-              <a:rPr lang="en-US" sz="2250" b="1" dirty="0" spc="-7" kern="0">
+              <a:rPr lang="en-US" sz="2250" b="1" dirty="0" spc="5" kern="0">
                 <a:solidFill>
                   <a:srgbClr val="7C93FF"/>
                 </a:solidFill>
@@ -9745,10 +9756,10 @@
                 <a:ea typeface="Be Vietnam Pro" pitchFamily="34" charset="-122"/>
                 <a:cs typeface="Be Vietnam Pro" pitchFamily="34" charset="-120"/>
               </a:rPr>
-              <a:t>Mạng</a:t>
-            </a:r>
-            <a:r>
-              <a:rPr lang="en-US" sz="2250" b="1" dirty="0" spc="-17" kern="0">
+              <a:t>Thứ</a:t>
+            </a:r>
+            <a:r>
+              <a:rPr lang="en-US" sz="2250" b="1" dirty="0" spc="1" kern="0">
                 <a:solidFill>
                   <a:srgbClr val="7C93FF"/>
                 </a:solidFill>
@@ -9756,10 +9767,10 @@
                 <a:ea typeface="Be Vietnam Pro" pitchFamily="34" charset="-122"/>
                 <a:cs typeface="Be Vietnam Pro" pitchFamily="34" charset="-120"/>
               </a:rPr>
-              <a:t> và</a:t>
-            </a:r>
-            <a:r>
-              <a:rPr lang="en-US" sz="2250" b="1" dirty="0" spc="30" kern="0">
+              <a:t> tự</a:t>
+            </a:r>
+            <a:r>
+              <a:rPr lang="en-US" sz="2250" b="1" dirty="0" spc="-3" kern="0">
                 <a:solidFill>
                   <a:srgbClr val="7C93FF"/>
                 </a:solidFill>
@@ -9767,18 +9778,7 @@
                 <a:ea typeface="Be Vietnam Pro" pitchFamily="34" charset="-122"/>
                 <a:cs typeface="Be Vietnam Pro" pitchFamily="34" charset="-120"/>
               </a:rPr>
-              <a:t> lưu</a:t>
-            </a:r>
-            <a:r>
-              <a:rPr lang="en-US" sz="2250" b="1" dirty="0" spc="-6" kern="0">
-                <a:solidFill>
-                  <a:srgbClr val="7C93FF"/>
-                </a:solidFill>
-                <a:latin typeface="Be Vietnam Pro" pitchFamily="34" charset="0"/>
-                <a:ea typeface="Be Vietnam Pro" pitchFamily="34" charset="-122"/>
-                <a:cs typeface="Be Vietnam Pro" pitchFamily="34" charset="-120"/>
-              </a:rPr>
-              <a:t> tệp</a:t>
+              <a:t> mạng</a:t>
             </a:r>
             <a:endParaRPr lang="en-US" sz="2250" dirty="0"/>
           </a:p>
@@ -11354,15 +11354,26 @@
               <a:buNone/>
             </a:pPr>
             <a:r>
-              <a:rPr lang="en-US" sz="2850" dirty="0" spc="-2" kern="0">
-                <a:solidFill>
-                  <a:srgbClr val="14161C"/>
-                </a:solidFill>
-                <a:latin typeface="Be Vietnam Pro" pitchFamily="34" charset="0"/>
-                <a:ea typeface="Be Vietnam Pro" pitchFamily="34" charset="-122"/>
-                <a:cs typeface="Be Vietnam Pro" pitchFamily="34" charset="-120"/>
-              </a:rPr>
-              <a:t>Dữ</a:t>
+              <a:rPr lang="en-US" sz="2850" dirty="0" spc="60" kern="0">
+                <a:solidFill>
+                  <a:srgbClr val="14161C"/>
+                </a:solidFill>
+                <a:latin typeface="Be Vietnam Pro" pitchFamily="34" charset="0"/>
+                <a:ea typeface="Be Vietnam Pro" pitchFamily="34" charset="-122"/>
+                <a:cs typeface="Be Vietnam Pro" pitchFamily="34" charset="-120"/>
+              </a:rPr>
+              <a:t>Gửi</a:t>
+            </a:r>
+            <a:r>
+              <a:rPr lang="en-US" sz="2850" dirty="0" spc="-1" kern="0">
+                <a:solidFill>
+                  <a:srgbClr val="14161C"/>
+                </a:solidFill>
+                <a:latin typeface="Be Vietnam Pro" pitchFamily="34" charset="0"/>
+                <a:ea typeface="Be Vietnam Pro" pitchFamily="34" charset="-122"/>
+                <a:cs typeface="Be Vietnam Pro" pitchFamily="34" charset="-120"/>
+              </a:rPr>
+              <a:t> dữ</a:t>
             </a:r>
             <a:r>
               <a:rPr lang="en-US" sz="2850" dirty="0" spc="2" kern="0">
@@ -11376,26 +11387,81 @@
               <a:t> liệu</a:t>
             </a:r>
             <a:r>
-              <a:rPr lang="en-US" sz="2850" dirty="0" spc="-15" kern="0">
-                <a:solidFill>
-                  <a:srgbClr val="14161C"/>
-                </a:solidFill>
-                <a:latin typeface="Be Vietnam Pro" pitchFamily="34" charset="0"/>
-                <a:ea typeface="Be Vietnam Pro" pitchFamily="34" charset="-122"/>
-                <a:cs typeface="Be Vietnam Pro" pitchFamily="34" charset="-120"/>
-              </a:rPr>
-              <a:t> chuyển</a:t>
-            </a:r>
-            <a:r>
-              <a:rPr lang="en-US" sz="2850" dirty="0" spc="9" kern="0">
-                <a:solidFill>
-                  <a:srgbClr val="14161C"/>
-                </a:solidFill>
-                <a:latin typeface="Be Vietnam Pro" pitchFamily="34" charset="0"/>
-                <a:ea typeface="Be Vietnam Pro" pitchFamily="34" charset="-122"/>
-                <a:cs typeface="Be Vietnam Pro" pitchFamily="34" charset="-120"/>
-              </a:rPr>
-              <a:t> giữa</a:t>
+              <a:rPr lang="en-US" sz="2850" dirty="0" spc="-34" kern="0">
+                <a:solidFill>
+                  <a:srgbClr val="14161C"/>
+                </a:solidFill>
+                <a:latin typeface="Be Vietnam Pro" pitchFamily="34" charset="0"/>
+                <a:ea typeface="Be Vietnam Pro" pitchFamily="34" charset="-122"/>
+                <a:cs typeface="Be Vietnam Pro" pitchFamily="34" charset="-120"/>
+              </a:rPr>
+              <a:t> ra</a:t>
+            </a:r>
+            <a:r>
+              <a:rPr lang="en-US" sz="2850" dirty="0" spc="-11" kern="0">
+                <a:solidFill>
+                  <a:srgbClr val="14161C"/>
+                </a:solidFill>
+                <a:latin typeface="Be Vietnam Pro" pitchFamily="34" charset="0"/>
+                <a:ea typeface="Be Vietnam Pro" pitchFamily="34" charset="-122"/>
+                <a:cs typeface="Be Vietnam Pro" pitchFamily="34" charset="-120"/>
+              </a:rPr>
+              <a:t> ngoài</a:t>
+            </a:r>
+            <a:r>
+              <a:rPr lang="en-US" sz="2850" dirty="0" spc="-1" kern="0">
+                <a:solidFill>
+                  <a:srgbClr val="14161C"/>
+                </a:solidFill>
+                <a:latin typeface="Be Vietnam Pro" pitchFamily="34" charset="0"/>
+                <a:ea typeface="Be Vietnam Pro" pitchFamily="34" charset="-122"/>
+                <a:cs typeface="Be Vietnam Pro" pitchFamily="34" charset="-120"/>
+              </a:rPr>
+              <a:t> tiến</a:t>
+            </a:r>
+            <a:r>
+              <a:rPr lang="en-US" sz="2850" dirty="0" spc="8" kern="0">
+                <a:solidFill>
+                  <a:srgbClr val="14161C"/>
+                </a:solidFill>
+                <a:latin typeface="Be Vietnam Pro" pitchFamily="34" charset="0"/>
+                <a:ea typeface="Be Vietnam Pro" pitchFamily="34" charset="-122"/>
+                <a:cs typeface="Be Vietnam Pro" pitchFamily="34" charset="-120"/>
+              </a:rPr>
+              <a:t> trình:</a:t>
+            </a:r>
+            <a:r>
+              <a:rPr lang="en-US" sz="2850" dirty="0" spc="21" kern="0">
+                <a:solidFill>
+                  <a:srgbClr val="14161C"/>
+                </a:solidFill>
+                <a:latin typeface="Be Vietnam Pro" pitchFamily="34" charset="0"/>
+                <a:ea typeface="Be Vietnam Pro" pitchFamily="34" charset="-122"/>
+                <a:cs typeface="Be Vietnam Pro" pitchFamily="34" charset="-120"/>
+              </a:rPr>
+              <a:t> đừng</a:t>
+            </a:r>
+            <a:r>
+              <a:rPr lang="en-US" sz="2850" dirty="0" spc="1" kern="0">
+                <a:solidFill>
+                  <a:srgbClr val="14161C"/>
+                </a:solidFill>
+                <a:latin typeface="Be Vietnam Pro" pitchFamily="34" charset="0"/>
+                <a:ea typeface="Be Vietnam Pro" pitchFamily="34" charset="-122"/>
+                <a:cs typeface="Be Vietnam Pro" pitchFamily="34" charset="-120"/>
+              </a:rPr>
+              <a:t> giả</a:t>
+            </a:r>
+            <a:r>
+              <a:rPr lang="en-US" sz="2850" dirty="0" spc="22" kern="0">
+                <a:solidFill>
+                  <a:srgbClr val="14161C"/>
+                </a:solidFill>
+                <a:latin typeface="Be Vietnam Pro" pitchFamily="34" charset="0"/>
+                <a:ea typeface="Be Vietnam Pro" pitchFamily="34" charset="-122"/>
+                <a:cs typeface="Be Vietnam Pro" pitchFamily="34" charset="-120"/>
+              </a:rPr>
+              <a:t> định</a:t>
             </a:r>
             <a:r>
               <a:rPr lang="en-US" sz="2850" dirty="0" spc="0" kern="0">
@@ -11406,7 +11472,29 @@
                 <a:ea typeface="Be Vietnam Pro" pitchFamily="34" charset="-122"/>
                 <a:cs typeface="Be Vietnam Pro" pitchFamily="34" charset="-120"/>
               </a:rPr>
-              <a:t> các</a:t>
+              <a:t> thứ</a:t>
+            </a:r>
+            <a:r>
+              <a:rPr lang="en-US" sz="2850" dirty="0" spc="-1" kern="0">
+                <a:solidFill>
+                  <a:srgbClr val="14161C"/>
+                </a:solidFill>
+                <a:latin typeface="Be Vietnam Pro" pitchFamily="34" charset="0"/>
+                <a:ea typeface="Be Vietnam Pro" pitchFamily="34" charset="-122"/>
+                <a:cs typeface="Be Vietnam Pro" pitchFamily="34" charset="-120"/>
+              </a:rPr>
+              <a:t> tự</a:t>
+            </a:r>
+            <a:r>
+              <a:rPr lang="en-US" sz="2850" dirty="0" spc="-20" kern="0">
+                <a:solidFill>
+                  <a:srgbClr val="14161C"/>
+                </a:solidFill>
+                <a:latin typeface="Be Vietnam Pro" pitchFamily="34" charset="0"/>
+                <a:ea typeface="Be Vietnam Pro" pitchFamily="34" charset="-122"/>
+                <a:cs typeface="Be Vietnam Pro" pitchFamily="34" charset="-120"/>
+              </a:rPr>
+              <a:t> gốc</a:t>
             </a:r>
             <a:r>
               <a:rPr lang="en-US" sz="2850" dirty="0" spc="1" kern="0">
@@ -11417,106 +11505,18 @@
                 <a:ea typeface="Be Vietnam Pro" pitchFamily="34" charset="-122"/>
                 <a:cs typeface="Be Vietnam Pro" pitchFamily="34" charset="-120"/>
               </a:rPr>
-              <a:t> hệ</a:t>
-            </a:r>
-            <a:r>
-              <a:rPr lang="en-US" sz="2850" dirty="0" spc="-2" kern="0">
-                <a:solidFill>
-                  <a:srgbClr val="14161C"/>
-                </a:solidFill>
-                <a:latin typeface="Be Vietnam Pro" pitchFamily="34" charset="0"/>
-                <a:ea typeface="Be Vietnam Pro" pitchFamily="34" charset="-122"/>
-                <a:cs typeface="Be Vietnam Pro" pitchFamily="34" charset="-120"/>
-              </a:rPr>
-              <a:t> thống, hoặc</a:t>
-            </a:r>
-            <a:r>
-              <a:rPr lang="en-US" sz="2850" dirty="0" spc="9" kern="0">
-                <a:solidFill>
-                  <a:srgbClr val="14161C"/>
-                </a:solidFill>
-                <a:latin typeface="Be Vietnam Pro" pitchFamily="34" charset="0"/>
-                <a:ea typeface="Be Vietnam Pro" pitchFamily="34" charset="-122"/>
-                <a:cs typeface="Be Vietnam Pro" pitchFamily="34" charset="-120"/>
-              </a:rPr>
-              <a:t> được</a:t>
-            </a:r>
-            <a:r>
-              <a:rPr lang="en-US" sz="2850" dirty="0" spc="3" kern="0">
-                <a:solidFill>
-                  <a:srgbClr val="14161C"/>
-                </a:solidFill>
-                <a:latin typeface="Be Vietnam Pro" pitchFamily="34" charset="0"/>
-                <a:ea typeface="Be Vietnam Pro" pitchFamily="34" charset="-122"/>
-                <a:cs typeface="Be Vietnam Pro" pitchFamily="34" charset="-120"/>
-              </a:rPr>
-              <a:t> xử</a:t>
-            </a:r>
-            <a:r>
-              <a:rPr lang="en-US" sz="2850" dirty="0" spc="2" kern="0">
-                <a:solidFill>
-                  <a:srgbClr val="14161C"/>
-                </a:solidFill>
-                <a:latin typeface="Be Vietnam Pro" pitchFamily="34" charset="0"/>
-                <a:ea typeface="Be Vietnam Pro" pitchFamily="34" charset="-122"/>
-                <a:cs typeface="Be Vietnam Pro" pitchFamily="34" charset="-120"/>
-              </a:rPr>
-              <a:t> lý</a:t>
-            </a:r>
-            <a:r>
-              <a:rPr lang="en-US" sz="2850" dirty="0" spc="-4" kern="0">
-                <a:solidFill>
-                  <a:srgbClr val="14161C"/>
-                </a:solidFill>
-                <a:latin typeface="Be Vietnam Pro" pitchFamily="34" charset="0"/>
-                <a:ea typeface="Be Vietnam Pro" pitchFamily="34" charset="-122"/>
-                <a:cs typeface="Be Vietnam Pro" pitchFamily="34" charset="-120"/>
-              </a:rPr>
-              <a:t> bởi</a:t>
-            </a:r>
-            <a:r>
-              <a:rPr lang="en-US" sz="2850" dirty="0" spc="1" kern="0">
-                <a:solidFill>
-                  <a:srgbClr val="14161C"/>
-                </a:solidFill>
-                <a:latin typeface="Be Vietnam Pro" pitchFamily="34" charset="0"/>
-                <a:ea typeface="Be Vietnam Pro" pitchFamily="34" charset="-122"/>
-                <a:cs typeface="Be Vietnam Pro" pitchFamily="34" charset="-120"/>
-              </a:rPr>
-              <a:t> hệ</a:t>
-            </a:r>
-            <a:r>
-              <a:rPr lang="en-US" sz="2850" dirty="0" spc="-2" kern="0">
-                <a:solidFill>
-                  <a:srgbClr val="14161C"/>
-                </a:solidFill>
-                <a:latin typeface="Be Vietnam Pro" pitchFamily="34" charset="0"/>
-                <a:ea typeface="Be Vietnam Pro" pitchFamily="34" charset="-122"/>
-                <a:cs typeface="Be Vietnam Pro" pitchFamily="34" charset="-120"/>
-              </a:rPr>
-              <a:t> thống</a:t>
-            </a:r>
-            <a:r>
-              <a:rPr lang="en-US" sz="2850" dirty="0" spc="-1" kern="0">
-                <a:solidFill>
-                  <a:srgbClr val="14161C"/>
-                </a:solidFill>
-                <a:latin typeface="Be Vietnam Pro" pitchFamily="34" charset="0"/>
-                <a:ea typeface="Be Vietnam Pro" pitchFamily="34" charset="-122"/>
-                <a:cs typeface="Be Vietnam Pro" pitchFamily="34" charset="-120"/>
-              </a:rPr>
-              <a:t> có thứ tự khác</a:t>
-            </a:r>
-            <a:r>
-              <a:rPr lang="en-US" sz="2850" dirty="0" spc="1" kern="0">
-                <a:solidFill>
-                  <a:srgbClr val="14161C"/>
-                </a:solidFill>
-                <a:latin typeface="Be Vietnam Pro" pitchFamily="34" charset="0"/>
-                <a:ea typeface="Be Vietnam Pro" pitchFamily="34" charset="-122"/>
-                <a:cs typeface="Be Vietnam Pro" pitchFamily="34" charset="-120"/>
-              </a:rPr>
-              <a:t> nhau.</a:t>
+              <a:t> của</a:t>
+            </a:r>
+            <a:r>
+              <a:rPr lang="en-US" sz="2850" dirty="0" spc="-8" kern="0">
+                <a:solidFill>
+                  <a:srgbClr val="14161C"/>
+                </a:solidFill>
+                <a:latin typeface="Be Vietnam Pro" pitchFamily="34" charset="0"/>
+                <a:ea typeface="Be Vietnam Pro" pitchFamily="34" charset="-122"/>
+                <a:cs typeface="Be Vietnam Pro" pitchFamily="34" charset="-120"/>
+              </a:rPr>
+              <a:t> máy.</a:t>
             </a:r>
             <a:endParaRPr lang="en-US" sz="2850" dirty="0"/>
           </a:p>
@@ -11707,59 +11707,81 @@
               <a:buChar char="•"/>
             </a:pPr>
             <a:r>
-              <a:rPr lang="en-US" sz="2550" dirty="0" spc="-40" kern="0">
-                <a:solidFill>
-                  <a:srgbClr val="14161C"/>
-                </a:solidFill>
-                <a:latin typeface="Be Vietnam Pro" pitchFamily="34" charset="0"/>
-                <a:ea typeface="Be Vietnam Pro" pitchFamily="34" charset="-122"/>
-                <a:cs typeface="Be Vietnam Pro" pitchFamily="34" charset="-120"/>
-              </a:rPr>
-              <a:t>Rắc</a:t>
-            </a:r>
-            <a:r>
-              <a:rPr lang="en-US" sz="2550" dirty="0" spc="-26" kern="0">
-                <a:solidFill>
-                  <a:srgbClr val="14161C"/>
-                </a:solidFill>
-                <a:latin typeface="Be Vietnam Pro" pitchFamily="34" charset="0"/>
-                <a:ea typeface="Be Vietnam Pro" pitchFamily="34" charset="-122"/>
-                <a:cs typeface="Be Vietnam Pro" pitchFamily="34" charset="-120"/>
-              </a:rPr>
-              <a:t> rối</a:t>
-            </a:r>
-            <a:r>
-              <a:rPr lang="en-US" sz="2550" dirty="0" spc="0" kern="0">
-                <a:solidFill>
-                  <a:srgbClr val="14161C"/>
-                </a:solidFill>
-                <a:latin typeface="Be Vietnam Pro" pitchFamily="34" charset="0"/>
-                <a:ea typeface="Be Vietnam Pro" pitchFamily="34" charset="-122"/>
-                <a:cs typeface="Be Vietnam Pro" pitchFamily="34" charset="-120"/>
-              </a:rPr>
-              <a:t> chỉ</a:t>
-            </a:r>
-            <a:r>
-              <a:rPr lang="en-US" sz="2550" dirty="0" spc="13" kern="0">
-                <a:solidFill>
-                  <a:srgbClr val="14161C"/>
-                </a:solidFill>
-                <a:latin typeface="Be Vietnam Pro" pitchFamily="34" charset="0"/>
-                <a:ea typeface="Be Vietnam Pro" pitchFamily="34" charset="-122"/>
-                <a:cs typeface="Be Vietnam Pro" pitchFamily="34" charset="-120"/>
-              </a:rPr>
-              <a:t> đến</a:t>
-            </a:r>
-            <a:r>
-              <a:rPr lang="en-US" sz="2550" dirty="0" spc="0" kern="0">
-                <a:solidFill>
-                  <a:srgbClr val="14161C"/>
-                </a:solidFill>
-                <a:latin typeface="Be Vietnam Pro" pitchFamily="34" charset="0"/>
-                <a:ea typeface="Be Vietnam Pro" pitchFamily="34" charset="-122"/>
-                <a:cs typeface="Be Vietnam Pro" pitchFamily="34" charset="-120"/>
-              </a:rPr>
-              <a:t> khi</a:t>
+              <a:rPr lang="en-US" sz="2550" dirty="0" spc="-62" kern="0">
+                <a:solidFill>
+                  <a:srgbClr val="14161C"/>
+                </a:solidFill>
+                <a:latin typeface="Be Vietnam Pro" pitchFamily="34" charset="0"/>
+                <a:ea typeface="Be Vietnam Pro" pitchFamily="34" charset="-122"/>
+                <a:cs typeface="Be Vietnam Pro" pitchFamily="34" charset="-120"/>
+              </a:rPr>
+              <a:t>Ra</a:t>
+            </a:r>
+            <a:r>
+              <a:rPr lang="en-US" sz="2550" dirty="0" spc="-11" kern="0">
+                <a:solidFill>
+                  <a:srgbClr val="14161C"/>
+                </a:solidFill>
+                <a:latin typeface="Be Vietnam Pro" pitchFamily="34" charset="0"/>
+                <a:ea typeface="Be Vietnam Pro" pitchFamily="34" charset="-122"/>
+                <a:cs typeface="Be Vietnam Pro" pitchFamily="34" charset="-120"/>
+              </a:rPr>
+              <a:t> ngoài</a:t>
+            </a:r>
+            <a:r>
+              <a:rPr lang="en-US" sz="2550" dirty="0" spc="1" kern="0">
+                <a:solidFill>
+                  <a:srgbClr val="14161C"/>
+                </a:solidFill>
+                <a:latin typeface="Be Vietnam Pro" pitchFamily="34" charset="0"/>
+                <a:ea typeface="Be Vietnam Pro" pitchFamily="34" charset="-122"/>
+                <a:cs typeface="Be Vietnam Pro" pitchFamily="34" charset="-120"/>
+              </a:rPr>
+              <a:t> tiến</a:t>
+            </a:r>
+            <a:r>
+              <a:rPr lang="en-US" sz="2550" dirty="0" spc="9" kern="0">
+                <a:solidFill>
+                  <a:srgbClr val="14161C"/>
+                </a:solidFill>
+                <a:latin typeface="Be Vietnam Pro" pitchFamily="34" charset="0"/>
+                <a:ea typeface="Be Vietnam Pro" pitchFamily="34" charset="-122"/>
+                <a:cs typeface="Be Vietnam Pro" pitchFamily="34" charset="-120"/>
+              </a:rPr>
+              <a:t> trình</a:t>
+            </a:r>
+            <a:r>
+              <a:rPr lang="en-US" sz="2550" dirty="0" spc="2" kern="0">
+                <a:solidFill>
+                  <a:srgbClr val="14161C"/>
+                </a:solidFill>
+                <a:latin typeface="Be Vietnam Pro" pitchFamily="34" charset="0"/>
+                <a:ea typeface="Be Vietnam Pro" pitchFamily="34" charset="-122"/>
+                <a:cs typeface="Be Vietnam Pro" pitchFamily="34" charset="-120"/>
+              </a:rPr>
+              <a:t> thì</a:t>
+            </a:r>
+            <a:r>
+              <a:rPr lang="en-US" sz="2550" dirty="0" spc="1" kern="0">
+                <a:solidFill>
+                  <a:srgbClr val="14161C"/>
+                </a:solidFill>
+                <a:latin typeface="Be Vietnam Pro" pitchFamily="34" charset="0"/>
+                <a:ea typeface="Be Vietnam Pro" pitchFamily="34" charset="-122"/>
+                <a:cs typeface="Be Vietnam Pro" pitchFamily="34" charset="-120"/>
+              </a:rPr>
+              <a:t> nêu</a:t>
+            </a:r>
+            <a:r>
+              <a:rPr lang="en-US" sz="2550" dirty="0" spc="-34" kern="0">
+                <a:solidFill>
+                  <a:srgbClr val="14161C"/>
+                </a:solidFill>
+                <a:latin typeface="Be Vietnam Pro" pitchFamily="34" charset="0"/>
+                <a:ea typeface="Be Vietnam Pro" pitchFamily="34" charset="-122"/>
+                <a:cs typeface="Be Vietnam Pro" pitchFamily="34" charset="-120"/>
+              </a:rPr>
+              <a:t> rõ</a:t>
             </a:r>
             <a:r>
               <a:rPr lang="en-US" sz="2550" dirty="0" spc="-1" kern="0">
@@ -11770,40 +11792,18 @@
                 <a:ea typeface="Be Vietnam Pro" pitchFamily="34" charset="-122"/>
                 <a:cs typeface="Be Vietnam Pro" pitchFamily="34" charset="-120"/>
               </a:rPr>
-              <a:t> hai</a:t>
-            </a:r>
-            <a:r>
-              <a:rPr lang="en-US" sz="2550" dirty="0" spc="-3" kern="0">
-                <a:solidFill>
-                  <a:srgbClr val="14161C"/>
-                </a:solidFill>
-                <a:latin typeface="Be Vietnam Pro" pitchFamily="34" charset="0"/>
-                <a:ea typeface="Be Vietnam Pro" pitchFamily="34" charset="-122"/>
-                <a:cs typeface="Be Vietnam Pro" pitchFamily="34" charset="-120"/>
-              </a:rPr>
-              <a:t> bên</a:t>
-            </a:r>
-            <a:r>
-              <a:rPr lang="en-US" sz="2550" dirty="0" spc="1" kern="0">
-                <a:solidFill>
-                  <a:srgbClr val="14161C"/>
-                </a:solidFill>
-                <a:latin typeface="Be Vietnam Pro" pitchFamily="34" charset="0"/>
-                <a:ea typeface="Be Vietnam Pro" pitchFamily="34" charset="-122"/>
-                <a:cs typeface="Be Vietnam Pro" pitchFamily="34" charset="-120"/>
-              </a:rPr>
-              <a:t> khác</a:t>
-            </a:r>
-            <a:r>
-              <a:rPr lang="en-US" sz="2550" dirty="0" spc="2" kern="0">
-                <a:solidFill>
-                  <a:srgbClr val="14161C"/>
-                </a:solidFill>
-                <a:latin typeface="Be Vietnam Pro" pitchFamily="34" charset="0"/>
-                <a:ea typeface="Be Vietnam Pro" pitchFamily="34" charset="-122"/>
-                <a:cs typeface="Be Vietnam Pro" pitchFamily="34" charset="-120"/>
-              </a:rPr>
-              <a:t> kiểu</a:t>
+              <a:t> thứ tự</a:t>
+            </a:r>
+            <a:r>
+              <a:rPr lang="en-US" sz="2550" dirty="0" spc="-17" kern="0">
+                <a:solidFill>
+                  <a:srgbClr val="14161C"/>
+                </a:solidFill>
+                <a:latin typeface="Be Vietnam Pro" pitchFamily="34" charset="0"/>
+                <a:ea typeface="Be Vietnam Pro" pitchFamily="34" charset="-122"/>
+                <a:cs typeface="Be Vietnam Pro" pitchFamily="34" charset="-120"/>
+              </a:rPr>
+              <a:t> byte</a:t>
             </a:r>
             <a:endParaRPr lang="en-US" sz="2550" dirty="0"/>
           </a:p>
@@ -11817,15 +11817,37 @@
               <a:buChar char="•"/>
             </a:pPr>
             <a:r>
-              <a:rPr lang="en-US" sz="2550" dirty="0" spc="-42" kern="0">
-                <a:solidFill>
-                  <a:srgbClr val="14161C"/>
-                </a:solidFill>
-                <a:latin typeface="Be Vietnam Pro" pitchFamily="34" charset="0"/>
-                <a:ea typeface="Be Vietnam Pro" pitchFamily="34" charset="-122"/>
-                <a:cs typeface="Be Vietnam Pro" pitchFamily="34" charset="-120"/>
-              </a:rPr>
-              <a:t>Xử</a:t>
+              <a:rPr lang="en-US" sz="2550" dirty="0" spc="-4" kern="0">
+                <a:solidFill>
+                  <a:srgbClr val="14161C"/>
+                </a:solidFill>
+                <a:latin typeface="Be Vietnam Pro" pitchFamily="34" charset="0"/>
+                <a:ea typeface="Be Vietnam Pro" pitchFamily="34" charset="-122"/>
+                <a:cs typeface="Be Vietnam Pro" pitchFamily="34" charset="-120"/>
+              </a:rPr>
+              <a:t>Thứ</a:t>
+            </a:r>
+            <a:r>
+              <a:rPr lang="en-US" sz="2550" dirty="0" spc="-1" kern="0">
+                <a:solidFill>
+                  <a:srgbClr val="14161C"/>
+                </a:solidFill>
+                <a:latin typeface="Be Vietnam Pro" pitchFamily="34" charset="0"/>
+                <a:ea typeface="Be Vietnam Pro" pitchFamily="34" charset="-122"/>
+                <a:cs typeface="Be Vietnam Pro" pitchFamily="34" charset="-120"/>
+              </a:rPr>
+              <a:t> tự</a:t>
+            </a:r>
+            <a:r>
+              <a:rPr lang="en-US" sz="2550" dirty="0" spc="1" kern="0">
+                <a:solidFill>
+                  <a:srgbClr val="14161C"/>
+                </a:solidFill>
+                <a:latin typeface="Be Vietnam Pro" pitchFamily="34" charset="0"/>
+                <a:ea typeface="Be Vietnam Pro" pitchFamily="34" charset="-122"/>
+                <a:cs typeface="Be Vietnam Pro" pitchFamily="34" charset="-120"/>
+              </a:rPr>
+              <a:t> mạng là</a:t>
             </a:r>
             <a:r>
               <a:rPr lang="en-US" sz="2550" dirty="0" spc="0" kern="0">
@@ -11836,7 +11858,7 @@
                 <a:ea typeface="Be Vietnam Pro" pitchFamily="34" charset="-122"/>
                 <a:cs typeface="Be Vietnam Pro" pitchFamily="34" charset="-120"/>
               </a:rPr>
-              <a:t> lý</a:t>
+              <a:t> big</a:t>
             </a:r>
             <a:r>
               <a:rPr lang="en-US" sz="2550" dirty="0" spc="-1" kern="0">
@@ -11847,62 +11869,7 @@
                 <a:ea typeface="Be Vietnam Pro" pitchFamily="34" charset="-122"/>
                 <a:cs typeface="Be Vietnam Pro" pitchFamily="34" charset="-120"/>
               </a:rPr>
-              <a:t> đúng thứ tự</a:t>
-            </a:r>
-            <a:r>
-              <a:rPr lang="en-US" sz="2550" dirty="0" spc="-17" kern="0">
-                <a:solidFill>
-                  <a:srgbClr val="14161C"/>
-                </a:solidFill>
-                <a:latin typeface="Be Vietnam Pro" pitchFamily="34" charset="0"/>
-                <a:ea typeface="Be Vietnam Pro" pitchFamily="34" charset="-122"/>
-                <a:cs typeface="Be Vietnam Pro" pitchFamily="34" charset="-120"/>
-              </a:rPr>
-              <a:t> byte</a:t>
-            </a:r>
-            <a:r>
-              <a:rPr lang="en-US" sz="2550" dirty="0" spc="18" kern="0">
-                <a:solidFill>
-                  <a:srgbClr val="14161C"/>
-                </a:solidFill>
-                <a:latin typeface="Be Vietnam Pro" pitchFamily="34" charset="0"/>
-                <a:ea typeface="Be Vietnam Pro" pitchFamily="34" charset="-122"/>
-                <a:cs typeface="Be Vietnam Pro" pitchFamily="34" charset="-120"/>
-              </a:rPr>
-              <a:t> để</a:t>
-            </a:r>
-            <a:r>
-              <a:rPr lang="en-US" sz="2550" dirty="0" spc="10" kern="0">
-                <a:solidFill>
-                  <a:srgbClr val="14161C"/>
-                </a:solidFill>
-                <a:latin typeface="Be Vietnam Pro" pitchFamily="34" charset="0"/>
-                <a:ea typeface="Be Vietnam Pro" pitchFamily="34" charset="-122"/>
-                <a:cs typeface="Be Vietnam Pro" pitchFamily="34" charset="-120"/>
-              </a:rPr>
-              <a:t> đọc</a:t>
-            </a:r>
-            <a:r>
-              <a:rPr lang="en-US" sz="2550" dirty="0" spc="-10" kern="0">
-                <a:solidFill>
-                  <a:srgbClr val="14161C"/>
-                </a:solidFill>
-                <a:latin typeface="Be Vietnam Pro" pitchFamily="34" charset="0"/>
-                <a:ea typeface="Be Vietnam Pro" pitchFamily="34" charset="-122"/>
-                <a:cs typeface="Be Vietnam Pro" pitchFamily="34" charset="-120"/>
-              </a:rPr>
-              <a:t> nhất</a:t>
-            </a:r>
-            <a:r>
-              <a:rPr lang="en-US" sz="2550" dirty="0" spc="1" kern="0">
-                <a:solidFill>
-                  <a:srgbClr val="14161C"/>
-                </a:solidFill>
-                <a:latin typeface="Be Vietnam Pro" pitchFamily="34" charset="0"/>
-                <a:ea typeface="Be Vietnam Pro" pitchFamily="34" charset="-122"/>
-                <a:cs typeface="Be Vietnam Pro" pitchFamily="34" charset="-120"/>
-              </a:rPr>
-              <a:t> quán</a:t>
+              <a:t> endian</a:t>
             </a:r>
             <a:endParaRPr lang="en-US" sz="2550" dirty="0"/>
           </a:p>
@@ -12231,15 +12198,26 @@
               <a:buNone/>
             </a:pPr>
             <a:r>
-              <a:rPr lang="en-US" sz="2700" b="1" dirty="0" spc="0" kern="0">
-                <a:solidFill>
-                  <a:srgbClr val="14161C"/>
-                </a:solidFill>
-                <a:latin typeface="Be Vietnam Pro" pitchFamily="34" charset="0"/>
-                <a:ea typeface="Be Vietnam Pro" pitchFamily="34" charset="-122"/>
-                <a:cs typeface="Be Vietnam Pro" pitchFamily="34" charset="-120"/>
-              </a:rPr>
-              <a:t>Dữ</a:t>
+              <a:rPr lang="en-US" sz="2700" b="1" dirty="0" spc="-2" kern="0">
+                <a:solidFill>
+                  <a:srgbClr val="14161C"/>
+                </a:solidFill>
+                <a:latin typeface="Be Vietnam Pro" pitchFamily="34" charset="0"/>
+                <a:ea typeface="Be Vietnam Pro" pitchFamily="34" charset="-122"/>
+                <a:cs typeface="Be Vietnam Pro" pitchFamily="34" charset="-120"/>
+              </a:rPr>
+              <a:t>Hai</a:t>
+            </a:r>
+            <a:r>
+              <a:rPr lang="en-US" sz="2700" b="1" dirty="0" spc="-14" kern="0">
+                <a:solidFill>
+                  <a:srgbClr val="14161C"/>
+                </a:solidFill>
+                <a:latin typeface="Be Vietnam Pro" pitchFamily="34" charset="0"/>
+                <a:ea typeface="Be Vietnam Pro" pitchFamily="34" charset="-122"/>
+                <a:cs typeface="Be Vietnam Pro" pitchFamily="34" charset="-120"/>
+              </a:rPr>
+              <a:t> máy</a:t>
             </a:r>
             <a:r>
               <a:rPr lang="en-US" sz="2700" b="1" dirty="0" spc="1" kern="0">
@@ -12250,51 +12228,7 @@
                 <a:ea typeface="Be Vietnam Pro" pitchFamily="34" charset="-122"/>
                 <a:cs typeface="Be Vietnam Pro" pitchFamily="34" charset="-120"/>
               </a:rPr>
-              <a:t> liệu</a:t>
-            </a:r>
-            <a:r>
-              <a:rPr lang="en-US" sz="2700" b="1" dirty="0" spc="9" kern="0">
-                <a:solidFill>
-                  <a:srgbClr val="14161C"/>
-                </a:solidFill>
-                <a:latin typeface="Be Vietnam Pro" pitchFamily="34" charset="0"/>
-                <a:ea typeface="Be Vietnam Pro" pitchFamily="34" charset="-122"/>
-                <a:cs typeface="Be Vietnam Pro" pitchFamily="34" charset="-120"/>
-              </a:rPr>
-              <a:t> được</a:t>
-            </a:r>
-            <a:r>
-              <a:rPr lang="en-US" sz="2700" b="1" dirty="0" spc="0" kern="0">
-                <a:solidFill>
-                  <a:srgbClr val="14161C"/>
-                </a:solidFill>
-                <a:latin typeface="Be Vietnam Pro" pitchFamily="34" charset="0"/>
-                <a:ea typeface="Be Vietnam Pro" pitchFamily="34" charset="-122"/>
-                <a:cs typeface="Be Vietnam Pro" pitchFamily="34" charset="-120"/>
-              </a:rPr>
-              <a:t> xử</a:t>
-            </a:r>
-            <a:r>
-              <a:rPr lang="en-US" sz="2700" b="1" dirty="0" spc="-1" kern="0">
-                <a:solidFill>
-                  <a:srgbClr val="14161C"/>
-                </a:solidFill>
-                <a:latin typeface="Be Vietnam Pro" pitchFamily="34" charset="0"/>
-                <a:ea typeface="Be Vietnam Pro" pitchFamily="34" charset="-122"/>
-                <a:cs typeface="Be Vietnam Pro" pitchFamily="34" charset="-120"/>
-              </a:rPr>
-              <a:t> lý</a:t>
-            </a:r>
-            <a:r>
-              <a:rPr lang="en-US" sz="2700" b="1" dirty="0" spc="3" kern="0">
-                <a:solidFill>
-                  <a:srgbClr val="14161C"/>
-                </a:solidFill>
-                <a:latin typeface="Be Vietnam Pro" pitchFamily="34" charset="0"/>
-                <a:ea typeface="Be Vietnam Pro" pitchFamily="34" charset="-122"/>
-                <a:cs typeface="Be Vietnam Pro" pitchFamily="34" charset="-120"/>
-              </a:rPr>
-              <a:t> bởi</a:t>
+              <a:t> khác</a:t>
             </a:r>
             <a:endParaRPr lang="en-US" sz="2700" dirty="0"/>
           </a:p>
@@ -12306,28 +12240,6 @@
               <a:buNone/>
             </a:pPr>
             <a:r>
-              <a:rPr lang="en-US" sz="2700" b="1" dirty="0" spc="-3" kern="0">
-                <a:solidFill>
-                  <a:srgbClr val="14161C"/>
-                </a:solidFill>
-                <a:latin typeface="Be Vietnam Pro" pitchFamily="34" charset="0"/>
-                <a:ea typeface="Be Vietnam Pro" pitchFamily="34" charset="-122"/>
-                <a:cs typeface="Be Vietnam Pro" pitchFamily="34" charset="-120"/>
-              </a:rPr>
-              <a:t>hệ</a:t>
-            </a:r>
-            <a:r>
-              <a:rPr lang="en-US" sz="2700" b="1" dirty="0" spc="-8" kern="0">
-                <a:solidFill>
-                  <a:srgbClr val="14161C"/>
-                </a:solidFill>
-                <a:latin typeface="Be Vietnam Pro" pitchFamily="34" charset="0"/>
-                <a:ea typeface="Be Vietnam Pro" pitchFamily="34" charset="-122"/>
-                <a:cs typeface="Be Vietnam Pro" pitchFamily="34" charset="-120"/>
-              </a:rPr>
-              <a:t> thống</a:t>
-            </a:r>
-            <a:r>
               <a:rPr lang="en-US" sz="2700" b="1" dirty="0" spc="-1" kern="0">
                 <a:solidFill>
                   <a:srgbClr val="14161C"/>
@@ -12336,7 +12248,7 @@
                 <a:ea typeface="Be Vietnam Pro" pitchFamily="34" charset="-122"/>
                 <a:cs typeface="Be Vietnam Pro" pitchFamily="34" charset="-120"/>
               </a:rPr>
-              <a:t> thứ</a:t>
+              <a:t>thứ</a:t>
             </a:r>
             <a:r>
               <a:rPr lang="en-US" sz="2700" b="1" dirty="0" spc="-4" kern="0">
@@ -12350,15 +12262,15 @@
               <a:t> tự</a:t>
             </a:r>
             <a:r>
-              <a:rPr lang="en-US" sz="2700" b="1" dirty="0" spc="1" kern="0">
-                <a:solidFill>
-                  <a:srgbClr val="14161C"/>
-                </a:solidFill>
-                <a:latin typeface="Be Vietnam Pro" pitchFamily="34" charset="0"/>
-                <a:ea typeface="Be Vietnam Pro" pitchFamily="34" charset="-122"/>
-                <a:cs typeface="Be Vietnam Pro" pitchFamily="34" charset="-120"/>
-              </a:rPr>
-              <a:t> khác nhau</a:t>
+              <a:rPr lang="en-US" sz="2700" b="1" dirty="0" spc="-12" kern="0">
+                <a:solidFill>
+                  <a:srgbClr val="14161C"/>
+                </a:solidFill>
+                <a:latin typeface="Be Vietnam Pro" pitchFamily="34" charset="0"/>
+                <a:ea typeface="Be Vietnam Pro" pitchFamily="34" charset="-122"/>
+                <a:cs typeface="Be Vietnam Pro" pitchFamily="34" charset="-120"/>
+              </a:rPr>
+              <a:t> byte</a:t>
             </a:r>
             <a:endParaRPr lang="en-US" sz="2700" dirty="0"/>
           </a:p>
@@ -12436,37 +12348,26 @@
               <a:buNone/>
             </a:pPr>
             <a:r>
-              <a:rPr lang="en-US" sz="3300" b="1" dirty="0" spc="-61" kern="0">
-                <a:solidFill>
-                  <a:srgbClr val="F3EEE3"/>
-                </a:solidFill>
-                <a:latin typeface="Be Vietnam Pro" pitchFamily="34" charset="0"/>
-                <a:ea typeface="Be Vietnam Pro" pitchFamily="34" charset="-122"/>
-                <a:cs typeface="Be Vietnam Pro" pitchFamily="34" charset="-120"/>
-              </a:rPr>
-              <a:t>Xử</a:t>
-            </a:r>
-            <a:r>
-              <a:rPr lang="en-US" sz="3300" b="1" dirty="0" spc="-3" kern="0">
-                <a:solidFill>
-                  <a:srgbClr val="F3EEE3"/>
-                </a:solidFill>
-                <a:latin typeface="Be Vietnam Pro" pitchFamily="34" charset="0"/>
-                <a:ea typeface="Be Vietnam Pro" pitchFamily="34" charset="-122"/>
-                <a:cs typeface="Be Vietnam Pro" pitchFamily="34" charset="-120"/>
-              </a:rPr>
-              <a:t> lý</a:t>
-            </a:r>
-            <a:r>
-              <a:rPr lang="en-US" sz="3300" b="1" dirty="0" spc="-7" kern="0">
-                <a:solidFill>
-                  <a:srgbClr val="F3EEE3"/>
-                </a:solidFill>
-                <a:latin typeface="Be Vietnam Pro" pitchFamily="34" charset="0"/>
-                <a:ea typeface="Be Vietnam Pro" pitchFamily="34" charset="-122"/>
-                <a:cs typeface="Be Vietnam Pro" pitchFamily="34" charset="-120"/>
-              </a:rPr>
-              <a:t> đúng</a:t>
+              <a:rPr lang="en-US" sz="3300" b="1" dirty="0" spc="-6" kern="0">
+                <a:solidFill>
+                  <a:srgbClr val="F3EEE3"/>
+                </a:solidFill>
+                <a:latin typeface="Be Vietnam Pro" pitchFamily="34" charset="0"/>
+                <a:ea typeface="Be Vietnam Pro" pitchFamily="34" charset="-122"/>
+                <a:cs typeface="Be Vietnam Pro" pitchFamily="34" charset="-120"/>
+              </a:rPr>
+              <a:t>Nêu</a:t>
+            </a:r>
+            <a:r>
+              <a:rPr lang="en-US" sz="3300" b="1" dirty="0" spc="-26" kern="0">
+                <a:solidFill>
+                  <a:srgbClr val="F3EEE3"/>
+                </a:solidFill>
+                <a:latin typeface="Be Vietnam Pro" pitchFamily="34" charset="0"/>
+                <a:ea typeface="Be Vietnam Pro" pitchFamily="34" charset="-122"/>
+                <a:cs typeface="Be Vietnam Pro" pitchFamily="34" charset="-120"/>
+              </a:rPr>
+              <a:t> rõ</a:t>
             </a:r>
             <a:r>
               <a:rPr lang="en-US" sz="3300" b="1" dirty="0" spc="-4" kern="0">
@@ -12477,21 +12378,10 @@
                 <a:ea typeface="Be Vietnam Pro" pitchFamily="34" charset="-122"/>
                 <a:cs typeface="Be Vietnam Pro" pitchFamily="34" charset="-120"/>
               </a:rPr>
-              <a:t> thứ</a:t>
-            </a:r>
-            <a:r>
-              <a:rPr lang="en-US" sz="3300" b="1" dirty="0" spc="-5" kern="0">
-                <a:solidFill>
-                  <a:srgbClr val="F3EEE3"/>
-                </a:solidFill>
-                <a:latin typeface="Be Vietnam Pro" pitchFamily="34" charset="0"/>
-                <a:ea typeface="Be Vietnam Pro" pitchFamily="34" charset="-122"/>
-                <a:cs typeface="Be Vietnam Pro" pitchFamily="34" charset="-120"/>
-              </a:rPr>
-              <a:t> tự</a:t>
-            </a:r>
-            <a:r>
-              <a:rPr lang="en-US" sz="3300" b="1" dirty="0" spc="-16" kern="0">
+              <a:t> thứ tự</a:t>
+            </a:r>
+            <a:r>
+              <a:rPr lang="en-US" sz="3300" b="1" dirty="0" spc="-17" kern="0">
                 <a:solidFill>
                   <a:srgbClr val="F3EEE3"/>
                 </a:solidFill>
@@ -12530,7 +12420,7 @@
               <a:buNone/>
             </a:pPr>
             <a:r>
-              <a:rPr lang="en-US" sz="2550" dirty="0" spc="27" kern="0">
+              <a:rPr lang="en-US" sz="2550" dirty="0" spc="0" kern="0">
                 <a:solidFill>
                   <a:srgbClr val="C4C8D6"/>
                 </a:solidFill>
@@ -12538,10 +12428,10 @@
                 <a:ea typeface="Be Vietnam Pro" pitchFamily="34" charset="-122"/>
                 <a:cs typeface="Be Vietnam Pro" pitchFamily="34" charset="-120"/>
               </a:rPr>
-              <a:t>để</a:t>
-            </a:r>
-            <a:r>
-              <a:rPr lang="en-US" sz="2550" dirty="0" spc="10" kern="0">
+              <a:t>khi</a:t>
+            </a:r>
+            <a:r>
+              <a:rPr lang="en-US" sz="2550" dirty="0" spc="-20" kern="0">
                 <a:solidFill>
                   <a:srgbClr val="C4C8D6"/>
                 </a:solidFill>
@@ -12549,7 +12439,18 @@
                 <a:ea typeface="Be Vietnam Pro" pitchFamily="34" charset="-122"/>
                 <a:cs typeface="Be Vietnam Pro" pitchFamily="34" charset="-120"/>
               </a:rPr>
-              <a:t> đọc</a:t>
+              <a:t> trao</a:t>
+            </a:r>
+            <a:r>
+              <a:rPr lang="en-US" sz="2550" dirty="0" spc="12" kern="0">
+                <a:solidFill>
+                  <a:srgbClr val="C4C8D6"/>
+                </a:solidFill>
+                <a:latin typeface="Be Vietnam Pro" pitchFamily="34" charset="0"/>
+                <a:ea typeface="Be Vietnam Pro" pitchFamily="34" charset="-122"/>
+                <a:cs typeface="Be Vietnam Pro" pitchFamily="34" charset="-120"/>
+              </a:rPr>
+              <a:t> đổi</a:t>
             </a:r>
             <a:r>
               <a:rPr lang="en-US" sz="2550" dirty="0" spc="-2" kern="0">
@@ -12572,28 +12473,6 @@
                 <a:cs typeface="Be Vietnam Pro" pitchFamily="34" charset="-120"/>
               </a:rPr>
               <a:t> liệu</a:t>
-            </a:r>
-            <a:r>
-              <a:rPr lang="en-US" sz="2550" dirty="0" spc="-10" kern="0">
-                <a:solidFill>
-                  <a:srgbClr val="C4C8D6"/>
-                </a:solidFill>
-                <a:latin typeface="Be Vietnam Pro" pitchFamily="34" charset="0"/>
-                <a:ea typeface="Be Vietnam Pro" pitchFamily="34" charset="-122"/>
-                <a:cs typeface="Be Vietnam Pro" pitchFamily="34" charset="-120"/>
-              </a:rPr>
-              <a:t> nhất</a:t>
-            </a:r>
-            <a:r>
-              <a:rPr lang="en-US" sz="2550" dirty="0" spc="2" kern="0">
-                <a:solidFill>
-                  <a:srgbClr val="C4C8D6"/>
-                </a:solidFill>
-                <a:latin typeface="Be Vietnam Pro" pitchFamily="34" charset="0"/>
-                <a:ea typeface="Be Vietnam Pro" pitchFamily="34" charset="-122"/>
-                <a:cs typeface="Be Vietnam Pro" pitchFamily="34" charset="-120"/>
-              </a:rPr>
-              <a:t> quán</a:t>
             </a:r>
             <a:endParaRPr lang="en-US" sz="2550" dirty="0"/>
           </a:p>
@@ -18311,7 +18190,18 @@
               <a:t> system-design-101:</a:t>
             </a:r>
             <a:r>
-              <a:rPr lang="en-US" sz="2400" dirty="0" spc="-1" kern="0">
+              <a:rPr lang="en-US" sz="2400" dirty="0" spc="-12" kern="0">
+                <a:solidFill>
+                  <a:srgbClr val="F3EEE3"/>
+                </a:solidFill>
+                <a:latin typeface="Be Vietnam Pro" pitchFamily="34" charset="0"/>
+                <a:ea typeface="Be Vietnam Pro" pitchFamily="34" charset="-122"/>
+                <a:cs typeface="Be Vietnam Pro" pitchFamily="34" charset="-120"/>
+              </a:rPr>
+              <a:t> tên</a:t>
+            </a:r>
+            <a:r>
+              <a:rPr lang="en-US" sz="2400" dirty="0" spc="0" kern="0">
                 <a:solidFill>
                   <a:srgbClr val="F3EEE3"/>
                 </a:solidFill>
@@ -18333,7 +18223,7 @@
               <a:t> thứ</a:t>
             </a:r>
             <a:r>
-              <a:rPr lang="en-US" sz="2400" dirty="0" spc="4" kern="0">
+              <a:rPr lang="en-US" sz="2400" dirty="0" spc="3" kern="0">
                 <a:solidFill>
                   <a:srgbClr val="F3EEE3"/>
                 </a:solidFill>
@@ -18344,37 +18234,15 @@
               <a:t> tự</a:t>
             </a:r>
             <a:r>
-              <a:rPr lang="en-US" sz="2400" dirty="0" spc="-13" kern="0">
-                <a:solidFill>
-                  <a:srgbClr val="F3EEE3"/>
-                </a:solidFill>
-                <a:latin typeface="Be Vietnam Pro" pitchFamily="34" charset="0"/>
-                <a:ea typeface="Be Vietnam Pro" pitchFamily="34" charset="-122"/>
-                <a:cs typeface="Be Vietnam Pro" pitchFamily="34" charset="-120"/>
-              </a:rPr>
-              <a:t> byte,</a:t>
-            </a:r>
-            <a:r>
-              <a:rPr lang="en-US" sz="2400" dirty="0" spc="1" kern="0">
-                <a:solidFill>
-                  <a:srgbClr val="F3EEE3"/>
-                </a:solidFill>
-                <a:latin typeface="Be Vietnam Pro" pitchFamily="34" charset="0"/>
-                <a:ea typeface="Be Vietnam Pro" pitchFamily="34" charset="-122"/>
-                <a:cs typeface="Be Vietnam Pro" pitchFamily="34" charset="-120"/>
-              </a:rPr>
-              <a:t> nơi</a:t>
-            </a:r>
-            <a:r>
-              <a:rPr lang="en-US" sz="2400" dirty="0" spc="3" kern="0">
-                <a:solidFill>
-                  <a:srgbClr val="F3EEE3"/>
-                </a:solidFill>
-                <a:latin typeface="Be Vietnam Pro" pitchFamily="34" charset="0"/>
-                <a:ea typeface="Be Vietnam Pro" pitchFamily="34" charset="-122"/>
-                <a:cs typeface="Be Vietnam Pro" pitchFamily="34" charset="-120"/>
-              </a:rPr>
-              <a:t> dùng</a:t>
+              <a:rPr lang="en-US" sz="2400" dirty="0" spc="-15" kern="0">
+                <a:solidFill>
+                  <a:srgbClr val="F3EEE3"/>
+                </a:solidFill>
+                <a:latin typeface="Be Vietnam Pro" pitchFamily="34" charset="0"/>
+                <a:ea typeface="Be Vietnam Pro" pitchFamily="34" charset="-122"/>
+                <a:cs typeface="Be Vietnam Pro" pitchFamily="34" charset="-120"/>
+              </a:rPr>
+              <a:t> byte</a:t>
             </a:r>
             <a:endParaRPr lang="en-US" sz="2400" dirty="0"/>
           </a:p>
@@ -18465,6 +18333,28 @@
               <a:t> 1023,</a:t>
             </a:r>
             <a:r>
+              <a:rPr lang="en-US" sz="2400" dirty="0" spc="-1" kern="0">
+                <a:solidFill>
+                  <a:srgbClr val="F3EEE3"/>
+                </a:solidFill>
+                <a:latin typeface="Be Vietnam Pro" pitchFamily="34" charset="0"/>
+                <a:ea typeface="Be Vietnam Pro" pitchFamily="34" charset="-122"/>
+                <a:cs typeface="Be Vietnam Pro" pitchFamily="34" charset="-120"/>
+              </a:rPr>
+              <a:t> các</a:t>
+            </a:r>
+            <a:r>
+              <a:rPr lang="en-US" sz="2400" dirty="0" spc="-4" kern="0">
+                <a:solidFill>
+                  <a:srgbClr val="F3EEE3"/>
+                </a:solidFill>
+                <a:latin typeface="Be Vietnam Pro" pitchFamily="34" charset="0"/>
+                <a:ea typeface="Be Vietnam Pro" pitchFamily="34" charset="-122"/>
+                <a:cs typeface="Be Vietnam Pro" pitchFamily="34" charset="-120"/>
+              </a:rPr>
+              <a:t> máy,</a:t>
+            </a:r>
+            <a:r>
               <a:rPr lang="en-US" sz="2400" dirty="0" spc="2" kern="0">
                 <a:solidFill>
                   <a:srgbClr val="F3EEE3"/>
@@ -18578,10 +18468,10 @@
                 <a:ea typeface="Be Vietnam Pro" pitchFamily="34" charset="-122"/>
                 <a:cs typeface="Be Vietnam Pro" pitchFamily="34" charset="-120"/>
               </a:rPr>
-              <a:t> 2026-10-18.</a:t>
-            </a:r>
-            <a:r>
-              <a:rPr lang="en-US" sz="1950" dirty="0" spc="0" kern="0">
+              <a:t> 2026-10-19.</a:t>
+            </a:r>
+            <a:r>
+              <a:rPr lang="en-US" sz="1950" dirty="0" spc="1" kern="0">
                 <a:solidFill>
                   <a:srgbClr val="9AA0B5"/>
                 </a:solidFill>
@@ -18603,7 +18493,7 @@
               <a:t> minh</a:t>
             </a:r>
             <a:r>
-              <a:rPr lang="en-US" sz="1950" dirty="0" spc="-3" kern="0">
+              <a:rPr lang="en-US" sz="1950" dirty="0" spc="-4" kern="0">
                 <a:solidFill>
                   <a:srgbClr val="9AA0B5"/>
                 </a:solidFill>

</xml_diff>

<commit_message>
Lesson sd-10-011: name the bytes by significance (trọng số cao nhất, thấp nhất) in the lesson, figure and deck
Co-Authored-By: Claude Sonnet 5.5 <noreply@anthropic.com>
Claude-Session: https://claude.ai/code/session_01Y9NYFwg4CcDYEWi1zr53gi
</commit_message>
<xml_diff>
--- a/system-design-101/vi/lessons/sd-10-011/slides/sd-10-011.pptx
+++ b/system-design-101/vi/lessons/sd-10-011/slides/sd-10-011.pptx
@@ -2662,7 +2662,7 @@
               <a:buNone/>
             </a:pPr>
             <a:r>
-              <a:rPr lang="en-US" sz="2850" b="1" dirty="0" spc="-9" kern="0">
+              <a:rPr lang="en-US" sz="2400" b="1" dirty="0" spc="-8" kern="0">
                 <a:solidFill>
                   <a:srgbClr val="F3EEE3"/>
                 </a:solidFill>
@@ -2673,18 +2673,40 @@
               <a:t>Byte</a:t>
             </a:r>
             <a:r>
-              <a:rPr lang="en-US" sz="2850" b="1" dirty="0" spc="-2" kern="0">
-                <a:solidFill>
-                  <a:srgbClr val="F3EEE3"/>
-                </a:solidFill>
-                <a:latin typeface="Be Vietnam Pro" pitchFamily="34" charset="0"/>
-                <a:ea typeface="Be Vietnam Pro" pitchFamily="34" charset="-122"/>
-                <a:cs typeface="Be Vietnam Pro" pitchFamily="34" charset="-120"/>
-              </a:rPr>
-              <a:t> lớn</a:t>
-            </a:r>
-            <a:r>
-              <a:rPr lang="en-US" sz="2850" b="1" dirty="0" spc="-7" kern="0">
+              <a:rPr lang="en-US" sz="2400" b="1" dirty="0" spc="-13" kern="0">
+                <a:solidFill>
+                  <a:srgbClr val="F3EEE3"/>
+                </a:solidFill>
+                <a:latin typeface="Be Vietnam Pro" pitchFamily="34" charset="0"/>
+                <a:ea typeface="Be Vietnam Pro" pitchFamily="34" charset="-122"/>
+                <a:cs typeface="Be Vietnam Pro" pitchFamily="34" charset="-120"/>
+              </a:rPr>
+              <a:t> trọng</a:t>
+            </a:r>
+            <a:r>
+              <a:rPr lang="en-US" sz="2400" b="1" dirty="0" spc="0" kern="0">
+                <a:solidFill>
+                  <a:srgbClr val="F3EEE3"/>
+                </a:solidFill>
+                <a:latin typeface="Be Vietnam Pro" pitchFamily="34" charset="0"/>
+                <a:ea typeface="Be Vietnam Pro" pitchFamily="34" charset="-122"/>
+                <a:cs typeface="Be Vietnam Pro" pitchFamily="34" charset="-120"/>
+              </a:rPr>
+              <a:t> số</a:t>
+            </a:r>
+            <a:r>
+              <a:rPr lang="en-US" sz="2400" b="1" dirty="0" spc="2" kern="0">
+                <a:solidFill>
+                  <a:srgbClr val="F3EEE3"/>
+                </a:solidFill>
+                <a:latin typeface="Be Vietnam Pro" pitchFamily="34" charset="0"/>
+                <a:ea typeface="Be Vietnam Pro" pitchFamily="34" charset="-122"/>
+                <a:cs typeface="Be Vietnam Pro" pitchFamily="34" charset="-120"/>
+              </a:rPr>
+              <a:t> cao</a:t>
+            </a:r>
+            <a:r>
+              <a:rPr lang="en-US" sz="2400" b="1" dirty="0" spc="-7" kern="0">
                 <a:solidFill>
                   <a:srgbClr val="F3EEE3"/>
                 </a:solidFill>
@@ -2695,7 +2717,7 @@
               <a:t> nhất</a:t>
             </a:r>
             <a:r>
-              <a:rPr lang="en-US" sz="2850" b="1" dirty="0" spc="11" kern="0">
+              <a:rPr lang="en-US" sz="2400" b="1" dirty="0" spc="10" kern="0">
                 <a:solidFill>
                   <a:srgbClr val="F3EEE3"/>
                 </a:solidFill>
@@ -2705,7 +2727,7 @@
               </a:rPr>
               <a:t> trước</a:t>
             </a:r>
-            <a:endParaRPr lang="en-US" sz="2850" dirty="0"/>
+            <a:endParaRPr lang="en-US" sz="2400" dirty="0"/>
           </a:p>
         </p:txBody>
       </p:sp>
@@ -2902,7 +2924,7 @@
               <a:buNone/>
             </a:pPr>
             <a:r>
-              <a:rPr lang="en-US" sz="2850" b="1" dirty="0" spc="-9" kern="0">
+              <a:rPr lang="en-US" sz="2325" b="1" dirty="0" spc="-5" kern="0">
                 <a:solidFill>
                   <a:srgbClr val="F3EEE3"/>
                 </a:solidFill>
@@ -2913,18 +2935,40 @@
               <a:t>Byte</a:t>
             </a:r>
             <a:r>
-              <a:rPr lang="en-US" sz="2850" b="1" dirty="0" spc="-2" kern="0">
-                <a:solidFill>
-                  <a:srgbClr val="F3EEE3"/>
-                </a:solidFill>
-                <a:latin typeface="Be Vietnam Pro" pitchFamily="34" charset="0"/>
-                <a:ea typeface="Be Vietnam Pro" pitchFamily="34" charset="-122"/>
-                <a:cs typeface="Be Vietnam Pro" pitchFamily="34" charset="-120"/>
-              </a:rPr>
-              <a:t> nhỏ</a:t>
-            </a:r>
-            <a:r>
-              <a:rPr lang="en-US" sz="2850" b="1" dirty="0" spc="-7" kern="0">
+              <a:rPr lang="en-US" sz="2325" b="1" dirty="0" spc="-13" kern="0">
+                <a:solidFill>
+                  <a:srgbClr val="F3EEE3"/>
+                </a:solidFill>
+                <a:latin typeface="Be Vietnam Pro" pitchFamily="34" charset="0"/>
+                <a:ea typeface="Be Vietnam Pro" pitchFamily="34" charset="-122"/>
+                <a:cs typeface="Be Vietnam Pro" pitchFamily="34" charset="-120"/>
+              </a:rPr>
+              <a:t> trọng</a:t>
+            </a:r>
+            <a:r>
+              <a:rPr lang="en-US" sz="2325" b="1" dirty="0" spc="-2" kern="0">
+                <a:solidFill>
+                  <a:srgbClr val="F3EEE3"/>
+                </a:solidFill>
+                <a:latin typeface="Be Vietnam Pro" pitchFamily="34" charset="0"/>
+                <a:ea typeface="Be Vietnam Pro" pitchFamily="34" charset="-122"/>
+                <a:cs typeface="Be Vietnam Pro" pitchFamily="34" charset="-120"/>
+              </a:rPr>
+              <a:t> số</a:t>
+            </a:r>
+            <a:r>
+              <a:rPr lang="en-US" sz="2325" b="1" dirty="0" spc="1" kern="0">
+                <a:solidFill>
+                  <a:srgbClr val="F3EEE3"/>
+                </a:solidFill>
+                <a:latin typeface="Be Vietnam Pro" pitchFamily="34" charset="0"/>
+                <a:ea typeface="Be Vietnam Pro" pitchFamily="34" charset="-122"/>
+                <a:cs typeface="Be Vietnam Pro" pitchFamily="34" charset="-120"/>
+              </a:rPr>
+              <a:t> thấp</a:t>
+            </a:r>
+            <a:r>
+              <a:rPr lang="en-US" sz="2325" b="1" dirty="0" spc="-4" kern="0">
                 <a:solidFill>
                   <a:srgbClr val="F3EEE3"/>
                 </a:solidFill>
@@ -2935,7 +2979,7 @@
               <a:t> nhất</a:t>
             </a:r>
             <a:r>
-              <a:rPr lang="en-US" sz="2850" b="1" dirty="0" spc="11" kern="0">
+              <a:rPr lang="en-US" sz="2325" b="1" dirty="0" spc="9" kern="0">
                 <a:solidFill>
                   <a:srgbClr val="F3EEE3"/>
                 </a:solidFill>
@@ -2945,7 +2989,7 @@
               </a:rPr>
               <a:t> trước</a:t>
             </a:r>
-            <a:endParaRPr lang="en-US" sz="2850" dirty="0"/>
+            <a:endParaRPr lang="en-US" sz="2325" dirty="0"/>
           </a:p>
         </p:txBody>
       </p:sp>
@@ -5756,26 +5800,15 @@
               <a:buNone/>
             </a:pPr>
             <a:r>
-              <a:rPr lang="en-US" sz="2250" b="1" dirty="0" spc="-11" kern="0">
-                <a:solidFill>
-                  <a:srgbClr val="14161C"/>
-                </a:solidFill>
-                <a:latin typeface="Be Vietnam Pro" pitchFamily="34" charset="0"/>
-                <a:ea typeface="Be Vietnam Pro" pitchFamily="34" charset="-122"/>
-                <a:cs typeface="Be Vietnam Pro" pitchFamily="34" charset="-120"/>
-              </a:rPr>
-              <a:t>byte</a:t>
-            </a:r>
-            <a:r>
-              <a:rPr lang="en-US" sz="2250" b="1" dirty="0" spc="-2" kern="0">
-                <a:solidFill>
-                  <a:srgbClr val="14161C"/>
-                </a:solidFill>
-                <a:latin typeface="Be Vietnam Pro" pitchFamily="34" charset="0"/>
-                <a:ea typeface="Be Vietnam Pro" pitchFamily="34" charset="-122"/>
-                <a:cs typeface="Be Vietnam Pro" pitchFamily="34" charset="-120"/>
-              </a:rPr>
-              <a:t> lớn</a:t>
+              <a:rPr lang="en-US" sz="2250" b="1" dirty="0" spc="5" kern="0">
+                <a:solidFill>
+                  <a:srgbClr val="14161C"/>
+                </a:solidFill>
+                <a:latin typeface="Be Vietnam Pro" pitchFamily="34" charset="0"/>
+                <a:ea typeface="Be Vietnam Pro" pitchFamily="34" charset="-122"/>
+                <a:cs typeface="Be Vietnam Pro" pitchFamily="34" charset="-120"/>
+              </a:rPr>
+              <a:t>cao</a:t>
             </a:r>
             <a:r>
               <a:rPr lang="en-US" sz="2250" b="1" dirty="0" spc="-3" kern="0">
@@ -5789,7 +5822,7 @@
               <a:t> nhất:</a:t>
             </a:r>
             <a:r>
-              <a:rPr lang="en-US" sz="2250" b="1" dirty="0" spc="3" kern="0">
+              <a:rPr lang="en-US" sz="2250" b="1" dirty="0" spc="2" kern="0">
                 <a:solidFill>
                   <a:srgbClr val="14161C"/>
                 </a:solidFill>
@@ -5837,7 +5870,7 @@
               <a:buNone/>
             </a:pPr>
             <a:r>
-              <a:rPr lang="en-US" sz="2250" b="1" dirty="0" spc="-11" kern="0">
+              <a:rPr lang="en-US" sz="2250" b="1" dirty="0" spc="1" kern="0">
                 <a:solidFill>
                   <a:srgbClr val="3DD6A0"/>
                 </a:solidFill>
@@ -5845,18 +5878,7 @@
                 <a:ea typeface="Be Vietnam Pro" pitchFamily="34" charset="-122"/>
                 <a:cs typeface="Be Vietnam Pro" pitchFamily="34" charset="-120"/>
               </a:rPr>
-              <a:t>byte</a:t>
-            </a:r>
-            <a:r>
-              <a:rPr lang="en-US" sz="2250" b="1" dirty="0" spc="0" kern="0">
-                <a:solidFill>
-                  <a:srgbClr val="3DD6A0"/>
-                </a:solidFill>
-                <a:latin typeface="Be Vietnam Pro" pitchFamily="34" charset="0"/>
-                <a:ea typeface="Be Vietnam Pro" pitchFamily="34" charset="-122"/>
-                <a:cs typeface="Be Vietnam Pro" pitchFamily="34" charset="-120"/>
-              </a:rPr>
-              <a:t> nhỏ</a:t>
+              <a:t>thấp</a:t>
             </a:r>
             <a:r>
               <a:rPr lang="en-US" sz="2250" b="1" dirty="0" spc="-3" kern="0">
@@ -6801,7 +6823,7 @@
               <a:buNone/>
             </a:pPr>
             <a:r>
-              <a:rPr lang="en-US" sz="2550" b="1" dirty="0" spc="-13" kern="0">
+              <a:rPr lang="en-US" sz="2100" b="1" dirty="0" spc="-12" kern="0">
                 <a:solidFill>
                   <a:srgbClr val="3DD6A0"/>
                 </a:solidFill>
@@ -6812,7 +6834,7 @@
               <a:t>byte</a:t>
             </a:r>
             <a:r>
-              <a:rPr lang="en-US" sz="2550" b="1" dirty="0" spc="-4" kern="0">
+              <a:rPr lang="en-US" sz="2100" b="1" dirty="0" spc="-14" kern="0">
                 <a:solidFill>
                   <a:srgbClr val="3DD6A0"/>
                 </a:solidFill>
@@ -6820,10 +6842,10 @@
                 <a:ea typeface="Be Vietnam Pro" pitchFamily="34" charset="-122"/>
                 <a:cs typeface="Be Vietnam Pro" pitchFamily="34" charset="-120"/>
               </a:rPr>
-              <a:t> lớn</a:t>
-            </a:r>
-            <a:r>
-              <a:rPr lang="en-US" sz="2550" b="1" dirty="0" spc="-6" kern="0">
+              <a:t> trọng</a:t>
+            </a:r>
+            <a:r>
+              <a:rPr lang="en-US" sz="2100" b="1" dirty="0" spc="-6" kern="0">
                 <a:solidFill>
                   <a:srgbClr val="3DD6A0"/>
                 </a:solidFill>
@@ -6831,9 +6853,20 @@
                 <a:ea typeface="Be Vietnam Pro" pitchFamily="34" charset="-122"/>
                 <a:cs typeface="Be Vietnam Pro" pitchFamily="34" charset="-120"/>
               </a:rPr>
-              <a:t> nhất</a:t>
-            </a:r>
-            <a:endParaRPr lang="en-US" sz="2550" dirty="0"/>
+              <a:t> số</a:t>
+            </a:r>
+            <a:r>
+              <a:rPr lang="en-US" sz="2100" b="1" dirty="0" spc="-5" kern="0">
+                <a:solidFill>
+                  <a:srgbClr val="3DD6A0"/>
+                </a:solidFill>
+                <a:latin typeface="Be Vietnam Pro" pitchFamily="34" charset="0"/>
+                <a:ea typeface="Be Vietnam Pro" pitchFamily="34" charset="-122"/>
+                <a:cs typeface="Be Vietnam Pro" pitchFamily="34" charset="-120"/>
+              </a:rPr>
+              <a:t> cao nhất</a:t>
+            </a:r>
+            <a:endParaRPr lang="en-US" sz="2100" dirty="0"/>
           </a:p>
         </p:txBody>
       </p:sp>
@@ -6862,7 +6895,7 @@
               <a:buNone/>
             </a:pPr>
             <a:r>
-              <a:rPr lang="en-US" sz="2550" b="1" dirty="0" spc="-13" kern="0">
+              <a:rPr lang="en-US" sz="2025" b="1" dirty="0" spc="-12" kern="0">
                 <a:solidFill>
                   <a:srgbClr val="3DD6A0"/>
                 </a:solidFill>
@@ -6873,7 +6906,7 @@
               <a:t>byte</a:t>
             </a:r>
             <a:r>
-              <a:rPr lang="en-US" sz="2550" b="1" dirty="0" spc="-3" kern="0">
+              <a:rPr lang="en-US" sz="2025" b="1" dirty="0" spc="-11" kern="0">
                 <a:solidFill>
                   <a:srgbClr val="3DD6A0"/>
                 </a:solidFill>
@@ -6881,10 +6914,10 @@
                 <a:ea typeface="Be Vietnam Pro" pitchFamily="34" charset="-122"/>
                 <a:cs typeface="Be Vietnam Pro" pitchFamily="34" charset="-120"/>
               </a:rPr>
-              <a:t> nhỏ</a:t>
-            </a:r>
-            <a:r>
-              <a:rPr lang="en-US" sz="2550" b="1" dirty="0" spc="-6" kern="0">
+              <a:t> trọng</a:t>
+            </a:r>
+            <a:r>
+              <a:rPr lang="en-US" sz="2025" b="1" dirty="0" spc="-4" kern="0">
                 <a:solidFill>
                   <a:srgbClr val="3DD6A0"/>
                 </a:solidFill>
@@ -6892,9 +6925,31 @@
                 <a:ea typeface="Be Vietnam Pro" pitchFamily="34" charset="-122"/>
                 <a:cs typeface="Be Vietnam Pro" pitchFamily="34" charset="-120"/>
               </a:rPr>
+              <a:t> số</a:t>
+            </a:r>
+            <a:r>
+              <a:rPr lang="en-US" sz="2025" b="1" dirty="0" spc="2" kern="0">
+                <a:solidFill>
+                  <a:srgbClr val="3DD6A0"/>
+                </a:solidFill>
+                <a:latin typeface="Be Vietnam Pro" pitchFamily="34" charset="0"/>
+                <a:ea typeface="Be Vietnam Pro" pitchFamily="34" charset="-122"/>
+                <a:cs typeface="Be Vietnam Pro" pitchFamily="34" charset="-120"/>
+              </a:rPr>
+              <a:t> thấp</a:t>
+            </a:r>
+            <a:r>
+              <a:rPr lang="en-US" sz="2025" b="1" dirty="0" spc="-3" kern="0">
+                <a:solidFill>
+                  <a:srgbClr val="3DD6A0"/>
+                </a:solidFill>
+                <a:latin typeface="Be Vietnam Pro" pitchFamily="34" charset="0"/>
+                <a:ea typeface="Be Vietnam Pro" pitchFamily="34" charset="-122"/>
+                <a:cs typeface="Be Vietnam Pro" pitchFamily="34" charset="-120"/>
+              </a:rPr>
               <a:t> nhất</a:t>
             </a:r>
-            <a:endParaRPr lang="en-US" sz="2550" dirty="0"/>
+            <a:endParaRPr lang="en-US" sz="2025" dirty="0"/>
           </a:p>
         </p:txBody>
       </p:sp>
@@ -6923,7 +6978,7 @@
               <a:buNone/>
             </a:pPr>
             <a:r>
-              <a:rPr lang="en-US" sz="1950" dirty="0" spc="1" kern="0">
+              <a:rPr lang="en-US" sz="1650" dirty="0" spc="-2" kern="0">
                 <a:solidFill>
                   <a:srgbClr val="9AA0B5"/>
                 </a:solidFill>
@@ -6934,7 +6989,7 @@
               <a:t>Màu</a:t>
             </a:r>
             <a:r>
-              <a:rPr lang="en-US" sz="1950" dirty="0" spc="8" kern="0">
+              <a:rPr lang="en-US" sz="1650" dirty="0" spc="8" kern="0">
                 <a:solidFill>
                   <a:srgbClr val="9AA0B5"/>
                 </a:solidFill>
@@ -6945,7 +7000,7 @@
               <a:t> đậm:</a:t>
             </a:r>
             <a:r>
-              <a:rPr lang="en-US" sz="1950" dirty="0" spc="-15" kern="0">
+              <a:rPr lang="en-US" sz="1650" dirty="0" spc="-9" kern="0">
                 <a:solidFill>
                   <a:srgbClr val="9AA0B5"/>
                 </a:solidFill>
@@ -6956,7 +7011,7 @@
               <a:t> byte</a:t>
             </a:r>
             <a:r>
-              <a:rPr lang="en-US" sz="1950" dirty="0" spc="0" kern="0">
+              <a:rPr lang="en-US" sz="1650" dirty="0" spc="-11" kern="0">
                 <a:solidFill>
                   <a:srgbClr val="9AA0B5"/>
                 </a:solidFill>
@@ -6964,10 +7019,10 @@
                 <a:ea typeface="Be Vietnam Pro" pitchFamily="34" charset="-122"/>
                 <a:cs typeface="Be Vietnam Pro" pitchFamily="34" charset="-120"/>
               </a:rPr>
-              <a:t> lớn</a:t>
-            </a:r>
-            <a:r>
-              <a:rPr lang="en-US" sz="1950" dirty="0" spc="-8" kern="0">
+              <a:t> trọng</a:t>
+            </a:r>
+            <a:r>
+              <a:rPr lang="en-US" sz="1650" dirty="0" spc="-3" kern="0">
                 <a:solidFill>
                   <a:srgbClr val="9AA0B5"/>
                 </a:solidFill>
@@ -6975,10 +7030,32 @@
                 <a:ea typeface="Be Vietnam Pro" pitchFamily="34" charset="-122"/>
                 <a:cs typeface="Be Vietnam Pro" pitchFamily="34" charset="-120"/>
               </a:rPr>
+              <a:t> số</a:t>
+            </a:r>
+            <a:r>
+              <a:rPr lang="en-US" sz="1650" dirty="0" spc="-1" kern="0">
+                <a:solidFill>
+                  <a:srgbClr val="9AA0B5"/>
+                </a:solidFill>
+                <a:latin typeface="Be Vietnam Pro" pitchFamily="34" charset="0"/>
+                <a:ea typeface="Be Vietnam Pro" pitchFamily="34" charset="-122"/>
+                <a:cs typeface="Be Vietnam Pro" pitchFamily="34" charset="-120"/>
+              </a:rPr>
+              <a:t> cao</a:t>
+            </a:r>
+            <a:r>
+              <a:rPr lang="en-US" sz="1650" dirty="0" spc="-5" kern="0">
+                <a:solidFill>
+                  <a:srgbClr val="9AA0B5"/>
+                </a:solidFill>
+                <a:latin typeface="Be Vietnam Pro" pitchFamily="34" charset="0"/>
+                <a:ea typeface="Be Vietnam Pro" pitchFamily="34" charset="-122"/>
+                <a:cs typeface="Be Vietnam Pro" pitchFamily="34" charset="-120"/>
+              </a:rPr>
               <a:t> nhất.</a:t>
             </a:r>
             <a:r>
-              <a:rPr lang="en-US" sz="1950" dirty="0" spc="1" kern="0">
+              <a:rPr lang="en-US" sz="1650" dirty="0" spc="0" kern="0">
                 <a:solidFill>
                   <a:srgbClr val="9AA0B5"/>
                 </a:solidFill>
@@ -6989,7 +7066,7 @@
               <a:t> Màu</a:t>
             </a:r>
             <a:r>
-              <a:rPr lang="en-US" sz="1950" dirty="0" spc="-8" kern="0">
+              <a:rPr lang="en-US" sz="1650" dirty="0" spc="-5" kern="0">
                 <a:solidFill>
                   <a:srgbClr val="9AA0B5"/>
                 </a:solidFill>
@@ -7000,7 +7077,7 @@
               <a:t> nhạt:</a:t>
             </a:r>
             <a:r>
-              <a:rPr lang="en-US" sz="1950" dirty="0" spc="-14" kern="0">
+              <a:rPr lang="en-US" sz="1650" dirty="0" spc="-9" kern="0">
                 <a:solidFill>
                   <a:srgbClr val="9AA0B5"/>
                 </a:solidFill>
@@ -7011,7 +7088,7 @@
               <a:t> byte</a:t>
             </a:r>
             <a:r>
-              <a:rPr lang="en-US" sz="1950" dirty="0" spc="0" kern="0">
+              <a:rPr lang="en-US" sz="1650" dirty="0" spc="-10" kern="0">
                 <a:solidFill>
                   <a:srgbClr val="9AA0B5"/>
                 </a:solidFill>
@@ -7019,10 +7096,10 @@
                 <a:ea typeface="Be Vietnam Pro" pitchFamily="34" charset="-122"/>
                 <a:cs typeface="Be Vietnam Pro" pitchFamily="34" charset="-120"/>
               </a:rPr>
-              <a:t> nhỏ</a:t>
-            </a:r>
-            <a:r>
-              <a:rPr lang="en-US" sz="1950" dirty="0" spc="-8" kern="0">
+              <a:t> trọng</a:t>
+            </a:r>
+            <a:r>
+              <a:rPr lang="en-US" sz="1650" dirty="0" spc="-4" kern="0">
                 <a:solidFill>
                   <a:srgbClr val="9AA0B5"/>
                 </a:solidFill>
@@ -7030,9 +7107,31 @@
                 <a:ea typeface="Be Vietnam Pro" pitchFamily="34" charset="-122"/>
                 <a:cs typeface="Be Vietnam Pro" pitchFamily="34" charset="-120"/>
               </a:rPr>
+              <a:t> số</a:t>
+            </a:r>
+            <a:r>
+              <a:rPr lang="en-US" sz="1650" dirty="0" spc="3" kern="0">
+                <a:solidFill>
+                  <a:srgbClr val="9AA0B5"/>
+                </a:solidFill>
+                <a:latin typeface="Be Vietnam Pro" pitchFamily="34" charset="0"/>
+                <a:ea typeface="Be Vietnam Pro" pitchFamily="34" charset="-122"/>
+                <a:cs typeface="Be Vietnam Pro" pitchFamily="34" charset="-120"/>
+              </a:rPr>
+              <a:t> thấp</a:t>
+            </a:r>
+            <a:r>
+              <a:rPr lang="en-US" sz="1650" dirty="0" spc="-5" kern="0">
+                <a:solidFill>
+                  <a:srgbClr val="9AA0B5"/>
+                </a:solidFill>
+                <a:latin typeface="Be Vietnam Pro" pitchFamily="34" charset="0"/>
+                <a:ea typeface="Be Vietnam Pro" pitchFamily="34" charset="-122"/>
+                <a:cs typeface="Be Vietnam Pro" pitchFamily="34" charset="-120"/>
+              </a:rPr>
               <a:t> nhất.</a:t>
             </a:r>
-            <a:endParaRPr lang="en-US" sz="1950" dirty="0"/>
+            <a:endParaRPr lang="en-US" sz="1650" dirty="0"/>
           </a:p>
         </p:txBody>
       </p:sp>
@@ -7570,6 +7669,17 @@
               <a:t>Byte</a:t>
             </a:r>
             <a:r>
+              <a:rPr lang="en-US" sz="3300" b="1" dirty="0" spc="-20" kern="0">
+                <a:solidFill>
+                  <a:srgbClr val="B45309"/>
+                </a:solidFill>
+                <a:latin typeface="Be Vietnam Pro" pitchFamily="34" charset="0"/>
+                <a:ea typeface="Be Vietnam Pro" pitchFamily="34" charset="-122"/>
+                <a:cs typeface="Be Vietnam Pro" pitchFamily="34" charset="-120"/>
+              </a:rPr>
+              <a:t> trọng</a:t>
+            </a:r>
+            <a:r>
               <a:rPr lang="en-US" sz="3300" b="1" dirty="0" spc="-8" kern="0">
                 <a:solidFill>
                   <a:srgbClr val="B45309"/>
@@ -7578,10 +7688,21 @@
                 <a:ea typeface="Be Vietnam Pro" pitchFamily="34" charset="-122"/>
                 <a:cs typeface="Be Vietnam Pro" pitchFamily="34" charset="-120"/>
               </a:rPr>
-              <a:t> nhỏ</a:t>
-            </a:r>
-            <a:r>
-              <a:rPr lang="en-US" sz="3300" b="1" dirty="0" spc="-13" kern="0">
+              <a:t> số</a:t>
+            </a:r>
+            <a:r>
+              <a:rPr lang="en-US" sz="3300" b="1" dirty="0" spc="-4" kern="0">
+                <a:solidFill>
+                  <a:srgbClr val="B45309"/>
+                </a:solidFill>
+                <a:latin typeface="Be Vietnam Pro" pitchFamily="34" charset="0"/>
+                <a:ea typeface="Be Vietnam Pro" pitchFamily="34" charset="-122"/>
+                <a:cs typeface="Be Vietnam Pro" pitchFamily="34" charset="-120"/>
+              </a:rPr>
+              <a:t> thấp</a:t>
+            </a:r>
+            <a:r>
+              <a:rPr lang="en-US" sz="3300" b="1" dirty="0" spc="-12" kern="0">
                 <a:solidFill>
                   <a:srgbClr val="B45309"/>
                 </a:solidFill>
@@ -8025,12 +8146,12 @@
           <a:ln/>
         </p:spPr>
         <p:txBody>
-          <a:bodyPr wrap="square" lIns="0" tIns="5667" rIns="0" bIns="-5667" rtlCol="0" anchor="t"/>
+          <a:bodyPr wrap="square" lIns="0" tIns="5501" rIns="0" bIns="-5501" rtlCol="0" anchor="t"/>
           <a:lstStyle/>
           <a:p>
-            <a:pPr algn="l" marL="323850" indent="-231371">
+            <a:pPr algn="l" marL="314325" indent="-224566">
               <a:lnSpc>
-                <a:spcPts val="3570"/>
+                <a:spcPts val="3465"/>
               </a:lnSpc>
               <a:spcAft>
                 <a:spcPts val="1050"/>
@@ -8040,7 +8161,7 @@
               <a:buChar char="•"/>
             </a:pPr>
             <a:r>
-              <a:rPr lang="en-US" sz="2550" dirty="0" spc="-3" kern="0">
+              <a:rPr lang="en-US" sz="2475" dirty="0" spc="-5" kern="0">
                 <a:solidFill>
                   <a:srgbClr val="14161C"/>
                 </a:solidFill>
@@ -8051,18 +8172,40 @@
               <a:t>Byte</a:t>
             </a:r>
             <a:r>
-              <a:rPr lang="en-US" sz="2550" dirty="0" spc="-1" kern="0">
-                <a:solidFill>
-                  <a:srgbClr val="14161C"/>
-                </a:solidFill>
-                <a:latin typeface="Be Vietnam Pro" pitchFamily="34" charset="0"/>
-                <a:ea typeface="Be Vietnam Pro" pitchFamily="34" charset="-122"/>
-                <a:cs typeface="Be Vietnam Pro" pitchFamily="34" charset="-120"/>
-              </a:rPr>
-              <a:t> nhỏ</a:t>
-            </a:r>
-            <a:r>
-              <a:rPr lang="en-US" sz="2550" dirty="0" spc="-10" kern="0">
+              <a:rPr lang="en-US" sz="2475" dirty="0" spc="-17" kern="0">
+                <a:solidFill>
+                  <a:srgbClr val="14161C"/>
+                </a:solidFill>
+                <a:latin typeface="Be Vietnam Pro" pitchFamily="34" charset="0"/>
+                <a:ea typeface="Be Vietnam Pro" pitchFamily="34" charset="-122"/>
+                <a:cs typeface="Be Vietnam Pro" pitchFamily="34" charset="-120"/>
+              </a:rPr>
+              <a:t> trọng</a:t>
+            </a:r>
+            <a:r>
+              <a:rPr lang="en-US" sz="2475" dirty="0" spc="-12" kern="0">
+                <a:solidFill>
+                  <a:srgbClr val="14161C"/>
+                </a:solidFill>
+                <a:latin typeface="Be Vietnam Pro" pitchFamily="34" charset="0"/>
+                <a:ea typeface="Be Vietnam Pro" pitchFamily="34" charset="-122"/>
+                <a:cs typeface="Be Vietnam Pro" pitchFamily="34" charset="-120"/>
+              </a:rPr>
+              <a:t> số</a:t>
+            </a:r>
+            <a:r>
+              <a:rPr lang="en-US" sz="2475" dirty="0" spc="0" kern="0">
+                <a:solidFill>
+                  <a:srgbClr val="14161C"/>
+                </a:solidFill>
+                <a:latin typeface="Be Vietnam Pro" pitchFamily="34" charset="0"/>
+                <a:ea typeface="Be Vietnam Pro" pitchFamily="34" charset="-122"/>
+                <a:cs typeface="Be Vietnam Pro" pitchFamily="34" charset="-120"/>
+              </a:rPr>
+              <a:t> thấp</a:t>
+            </a:r>
+            <a:r>
+              <a:rPr lang="en-US" sz="2475" dirty="0" spc="-9" kern="0">
                 <a:solidFill>
                   <a:srgbClr val="14161C"/>
                 </a:solidFill>
@@ -8073,7 +8216,7 @@
               <a:t> nhất</a:t>
             </a:r>
             <a:r>
-              <a:rPr lang="en-US" sz="2550" dirty="0" spc="0" kern="0">
+              <a:rPr lang="en-US" sz="2475" dirty="0" spc="-1" kern="0">
                 <a:solidFill>
                   <a:srgbClr val="14161C"/>
                 </a:solidFill>
@@ -8084,7 +8227,7 @@
               <a:t> ở</a:t>
             </a:r>
             <a:r>
-              <a:rPr lang="en-US" sz="2550" dirty="0" spc="26" kern="0">
+              <a:rPr lang="en-US" sz="2475" dirty="0" spc="23" kern="0">
                 <a:solidFill>
                   <a:srgbClr val="14161C"/>
                 </a:solidFill>
@@ -8095,7 +8238,7 @@
               <a:t> địa</a:t>
             </a:r>
             <a:r>
-              <a:rPr lang="en-US" sz="2550" dirty="0" spc="1" kern="0">
+              <a:rPr lang="en-US" sz="2475" dirty="0" spc="0" kern="0">
                 <a:solidFill>
                   <a:srgbClr val="14161C"/>
                 </a:solidFill>
@@ -8106,7 +8249,7 @@
               <a:t> chỉ thấp</a:t>
             </a:r>
             <a:r>
-              <a:rPr lang="en-US" sz="2550" dirty="0" spc="-10" kern="0">
+              <a:rPr lang="en-US" sz="2475" dirty="0" spc="-9" kern="0">
                 <a:solidFill>
                   <a:srgbClr val="14161C"/>
                 </a:solidFill>
@@ -8116,19 +8259,19 @@
               </a:rPr>
               <a:t> nhất</a:t>
             </a:r>
-            <a:endParaRPr lang="en-US" sz="2550" dirty="0"/>
-          </a:p>
-          <a:p>
-            <a:pPr algn="l" marL="323850" indent="-231371">
+            <a:endParaRPr lang="en-US" sz="2475" dirty="0"/>
+          </a:p>
+          <a:p>
+            <a:pPr algn="l" marL="314325" indent="-224566">
               <a:lnSpc>
-                <a:spcPts val="3570"/>
+                <a:spcPts val="3465"/>
               </a:lnSpc>
               <a:buSzPct val="100000"/>
               <a:buFont typeface="Arial"/>
               <a:buChar char="•"/>
             </a:pPr>
             <a:r>
-              <a:rPr lang="en-US" sz="2550" dirty="0" spc="-3" kern="0">
+              <a:rPr lang="en-US" sz="2475" dirty="0" spc="-5" kern="0">
                 <a:solidFill>
                   <a:srgbClr val="14161C"/>
                 </a:solidFill>
@@ -8139,18 +8282,40 @@
               <a:t>Byte</a:t>
             </a:r>
             <a:r>
-              <a:rPr lang="en-US" sz="2550" dirty="0" spc="-1" kern="0">
-                <a:solidFill>
-                  <a:srgbClr val="14161C"/>
-                </a:solidFill>
-                <a:latin typeface="Be Vietnam Pro" pitchFamily="34" charset="0"/>
-                <a:ea typeface="Be Vietnam Pro" pitchFamily="34" charset="-122"/>
-                <a:cs typeface="Be Vietnam Pro" pitchFamily="34" charset="-120"/>
-              </a:rPr>
-              <a:t> lớn</a:t>
-            </a:r>
-            <a:r>
-              <a:rPr lang="en-US" sz="2550" dirty="0" spc="-9" kern="0">
+              <a:rPr lang="en-US" sz="2475" dirty="0" spc="-17" kern="0">
+                <a:solidFill>
+                  <a:srgbClr val="14161C"/>
+                </a:solidFill>
+                <a:latin typeface="Be Vietnam Pro" pitchFamily="34" charset="0"/>
+                <a:ea typeface="Be Vietnam Pro" pitchFamily="34" charset="-122"/>
+                <a:cs typeface="Be Vietnam Pro" pitchFamily="34" charset="-120"/>
+              </a:rPr>
+              <a:t> trọng</a:t>
+            </a:r>
+            <a:r>
+              <a:rPr lang="en-US" sz="2475" dirty="0" spc="-12" kern="0">
+                <a:solidFill>
+                  <a:srgbClr val="14161C"/>
+                </a:solidFill>
+                <a:latin typeface="Be Vietnam Pro" pitchFamily="34" charset="0"/>
+                <a:ea typeface="Be Vietnam Pro" pitchFamily="34" charset="-122"/>
+                <a:cs typeface="Be Vietnam Pro" pitchFamily="34" charset="-120"/>
+              </a:rPr>
+              <a:t> số</a:t>
+            </a:r>
+            <a:r>
+              <a:rPr lang="en-US" sz="2475" dirty="0" spc="0" kern="0">
+                <a:solidFill>
+                  <a:srgbClr val="14161C"/>
+                </a:solidFill>
+                <a:latin typeface="Be Vietnam Pro" pitchFamily="34" charset="0"/>
+                <a:ea typeface="Be Vietnam Pro" pitchFamily="34" charset="-122"/>
+                <a:cs typeface="Be Vietnam Pro" pitchFamily="34" charset="-120"/>
+              </a:rPr>
+              <a:t> cao</a:t>
+            </a:r>
+            <a:r>
+              <a:rPr lang="en-US" sz="2475" dirty="0" spc="-8" kern="0">
                 <a:solidFill>
                   <a:srgbClr val="14161C"/>
                 </a:solidFill>
@@ -8161,7 +8326,7 @@
               <a:t> nhất</a:t>
             </a:r>
             <a:r>
-              <a:rPr lang="en-US" sz="2550" dirty="0" spc="-2" kern="0">
+              <a:rPr lang="en-US" sz="2475" dirty="0" spc="-3" kern="0">
                 <a:solidFill>
                   <a:srgbClr val="14161C"/>
                 </a:solidFill>
@@ -8172,7 +8337,7 @@
               <a:t> ở</a:t>
             </a:r>
             <a:r>
-              <a:rPr lang="en-US" sz="2550" dirty="0" spc="26" kern="0">
+              <a:rPr lang="en-US" sz="2475" dirty="0" spc="23" kern="0">
                 <a:solidFill>
                   <a:srgbClr val="14161C"/>
                 </a:solidFill>
@@ -8183,7 +8348,7 @@
               <a:t> địa</a:t>
             </a:r>
             <a:r>
-              <a:rPr lang="en-US" sz="2550" dirty="0" spc="1" kern="0">
+              <a:rPr lang="en-US" sz="2475" dirty="0" spc="0" kern="0">
                 <a:solidFill>
                   <a:srgbClr val="14161C"/>
                 </a:solidFill>
@@ -8194,7 +8359,7 @@
               <a:t> chỉ</a:t>
             </a:r>
             <a:r>
-              <a:rPr lang="en-US" sz="2550" dirty="0" spc="-37" kern="0">
+              <a:rPr lang="en-US" sz="2475" dirty="0" spc="-42" kern="0">
                 <a:solidFill>
                   <a:srgbClr val="14161C"/>
                 </a:solidFill>
@@ -8205,7 +8370,7 @@
               <a:t> kế</a:t>
             </a:r>
             <a:r>
-              <a:rPr lang="en-US" sz="2550" dirty="0" spc="1" kern="0">
+              <a:rPr lang="en-US" sz="2475" dirty="0" spc="-2" kern="0">
                 <a:solidFill>
                   <a:srgbClr val="14161C"/>
                 </a:solidFill>
@@ -8215,7 +8380,7 @@
               </a:rPr>
               <a:t> tiếp</a:t>
             </a:r>
-            <a:endParaRPr lang="en-US" sz="2550" dirty="0"/>
+            <a:endParaRPr lang="en-US" sz="2475" dirty="0"/>
           </a:p>
         </p:txBody>
       </p:sp>
@@ -8481,7 +8646,7 @@
               <a:buNone/>
             </a:pPr>
             <a:r>
-              <a:rPr lang="en-US" sz="2550" b="1" dirty="0" spc="-13" kern="0">
+              <a:rPr lang="en-US" sz="2025" b="1" dirty="0" spc="-12" kern="0">
                 <a:solidFill>
                   <a:srgbClr val="B45309"/>
                 </a:solidFill>
@@ -8492,7 +8657,7 @@
               <a:t>byte</a:t>
             </a:r>
             <a:r>
-              <a:rPr lang="en-US" sz="2550" b="1" dirty="0" spc="-3" kern="0">
+              <a:rPr lang="en-US" sz="2025" b="1" dirty="0" spc="-11" kern="0">
                 <a:solidFill>
                   <a:srgbClr val="B45309"/>
                 </a:solidFill>
@@ -8500,10 +8665,10 @@
                 <a:ea typeface="Be Vietnam Pro" pitchFamily="34" charset="-122"/>
                 <a:cs typeface="Be Vietnam Pro" pitchFamily="34" charset="-120"/>
               </a:rPr>
-              <a:t> nhỏ</a:t>
-            </a:r>
-            <a:r>
-              <a:rPr lang="en-US" sz="2550" b="1" dirty="0" spc="-6" kern="0">
+              <a:t> trọng</a:t>
+            </a:r>
+            <a:r>
+              <a:rPr lang="en-US" sz="2025" b="1" dirty="0" spc="-4" kern="0">
                 <a:solidFill>
                   <a:srgbClr val="B45309"/>
                 </a:solidFill>
@@ -8511,9 +8676,31 @@
                 <a:ea typeface="Be Vietnam Pro" pitchFamily="34" charset="-122"/>
                 <a:cs typeface="Be Vietnam Pro" pitchFamily="34" charset="-120"/>
               </a:rPr>
+              <a:t> số</a:t>
+            </a:r>
+            <a:r>
+              <a:rPr lang="en-US" sz="2025" b="1" dirty="0" spc="2" kern="0">
+                <a:solidFill>
+                  <a:srgbClr val="B45309"/>
+                </a:solidFill>
+                <a:latin typeface="Be Vietnam Pro" pitchFamily="34" charset="0"/>
+                <a:ea typeface="Be Vietnam Pro" pitchFamily="34" charset="-122"/>
+                <a:cs typeface="Be Vietnam Pro" pitchFamily="34" charset="-120"/>
+              </a:rPr>
+              <a:t> thấp</a:t>
+            </a:r>
+            <a:r>
+              <a:rPr lang="en-US" sz="2025" b="1" dirty="0" spc="-3" kern="0">
+                <a:solidFill>
+                  <a:srgbClr val="B45309"/>
+                </a:solidFill>
+                <a:latin typeface="Be Vietnam Pro" pitchFamily="34" charset="0"/>
+                <a:ea typeface="Be Vietnam Pro" pitchFamily="34" charset="-122"/>
+                <a:cs typeface="Be Vietnam Pro" pitchFamily="34" charset="-120"/>
+              </a:rPr>
               <a:t> nhất</a:t>
             </a:r>
-            <a:endParaRPr lang="en-US" sz="2550" dirty="0"/>
+            <a:endParaRPr lang="en-US" sz="2025" dirty="0"/>
           </a:p>
         </p:txBody>
       </p:sp>
@@ -8542,7 +8729,7 @@
               <a:buNone/>
             </a:pPr>
             <a:r>
-              <a:rPr lang="en-US" sz="2550" b="1" dirty="0" spc="-13" kern="0">
+              <a:rPr lang="en-US" sz="2100" b="1" dirty="0" spc="-12" kern="0">
                 <a:solidFill>
                   <a:srgbClr val="B45309"/>
                 </a:solidFill>
@@ -8553,7 +8740,7 @@
               <a:t>byte</a:t>
             </a:r>
             <a:r>
-              <a:rPr lang="en-US" sz="2550" b="1" dirty="0" spc="-4" kern="0">
+              <a:rPr lang="en-US" sz="2100" b="1" dirty="0" spc="-14" kern="0">
                 <a:solidFill>
                   <a:srgbClr val="B45309"/>
                 </a:solidFill>
@@ -8561,10 +8748,10 @@
                 <a:ea typeface="Be Vietnam Pro" pitchFamily="34" charset="-122"/>
                 <a:cs typeface="Be Vietnam Pro" pitchFamily="34" charset="-120"/>
               </a:rPr>
-              <a:t> lớn</a:t>
-            </a:r>
-            <a:r>
-              <a:rPr lang="en-US" sz="2550" b="1" dirty="0" spc="-6" kern="0">
+              <a:t> trọng</a:t>
+            </a:r>
+            <a:r>
+              <a:rPr lang="en-US" sz="2100" b="1" dirty="0" spc="-6" kern="0">
                 <a:solidFill>
                   <a:srgbClr val="B45309"/>
                 </a:solidFill>
@@ -8572,9 +8759,20 @@
                 <a:ea typeface="Be Vietnam Pro" pitchFamily="34" charset="-122"/>
                 <a:cs typeface="Be Vietnam Pro" pitchFamily="34" charset="-120"/>
               </a:rPr>
-              <a:t> nhất</a:t>
-            </a:r>
-            <a:endParaRPr lang="en-US" sz="2550" dirty="0"/>
+              <a:t> số</a:t>
+            </a:r>
+            <a:r>
+              <a:rPr lang="en-US" sz="2100" b="1" dirty="0" spc="-5" kern="0">
+                <a:solidFill>
+                  <a:srgbClr val="B45309"/>
+                </a:solidFill>
+                <a:latin typeface="Be Vietnam Pro" pitchFamily="34" charset="0"/>
+                <a:ea typeface="Be Vietnam Pro" pitchFamily="34" charset="-122"/>
+                <a:cs typeface="Be Vietnam Pro" pitchFamily="34" charset="-120"/>
+              </a:rPr>
+              <a:t> cao nhất</a:t>
+            </a:r>
+            <a:endParaRPr lang="en-US" sz="2100" dirty="0"/>
           </a:p>
         </p:txBody>
       </p:sp>
@@ -8761,7 +8959,7 @@
               <a:buNone/>
             </a:pPr>
             <a:r>
-              <a:rPr lang="en-US" sz="1950" dirty="0" spc="1" kern="0">
+              <a:rPr lang="en-US" sz="1650" dirty="0" spc="-2" kern="0">
                 <a:solidFill>
                   <a:srgbClr val="6B6A66"/>
                 </a:solidFill>
@@ -8772,7 +8970,7 @@
               <a:t>Màu</a:t>
             </a:r>
             <a:r>
-              <a:rPr lang="en-US" sz="1950" dirty="0" spc="8" kern="0">
+              <a:rPr lang="en-US" sz="1650" dirty="0" spc="8" kern="0">
                 <a:solidFill>
                   <a:srgbClr val="6B6A66"/>
                 </a:solidFill>
@@ -8783,7 +8981,7 @@
               <a:t> đậm:</a:t>
             </a:r>
             <a:r>
-              <a:rPr lang="en-US" sz="1950" dirty="0" spc="-15" kern="0">
+              <a:rPr lang="en-US" sz="1650" dirty="0" spc="-9" kern="0">
                 <a:solidFill>
                   <a:srgbClr val="6B6A66"/>
                 </a:solidFill>
@@ -8794,7 +8992,7 @@
               <a:t> byte</a:t>
             </a:r>
             <a:r>
-              <a:rPr lang="en-US" sz="1950" dirty="0" spc="0" kern="0">
+              <a:rPr lang="en-US" sz="1650" dirty="0" spc="-11" kern="0">
                 <a:solidFill>
                   <a:srgbClr val="6B6A66"/>
                 </a:solidFill>
@@ -8802,10 +9000,10 @@
                 <a:ea typeface="Be Vietnam Pro" pitchFamily="34" charset="-122"/>
                 <a:cs typeface="Be Vietnam Pro" pitchFamily="34" charset="-120"/>
               </a:rPr>
-              <a:t> lớn</a:t>
-            </a:r>
-            <a:r>
-              <a:rPr lang="en-US" sz="1950" dirty="0" spc="-8" kern="0">
+              <a:t> trọng</a:t>
+            </a:r>
+            <a:r>
+              <a:rPr lang="en-US" sz="1650" dirty="0" spc="-3" kern="0">
                 <a:solidFill>
                   <a:srgbClr val="6B6A66"/>
                 </a:solidFill>
@@ -8813,10 +9011,32 @@
                 <a:ea typeface="Be Vietnam Pro" pitchFamily="34" charset="-122"/>
                 <a:cs typeface="Be Vietnam Pro" pitchFamily="34" charset="-120"/>
               </a:rPr>
+              <a:t> số</a:t>
+            </a:r>
+            <a:r>
+              <a:rPr lang="en-US" sz="1650" dirty="0" spc="-1" kern="0">
+                <a:solidFill>
+                  <a:srgbClr val="6B6A66"/>
+                </a:solidFill>
+                <a:latin typeface="Be Vietnam Pro" pitchFamily="34" charset="0"/>
+                <a:ea typeface="Be Vietnam Pro" pitchFamily="34" charset="-122"/>
+                <a:cs typeface="Be Vietnam Pro" pitchFamily="34" charset="-120"/>
+              </a:rPr>
+              <a:t> cao</a:t>
+            </a:r>
+            <a:r>
+              <a:rPr lang="en-US" sz="1650" dirty="0" spc="-5" kern="0">
+                <a:solidFill>
+                  <a:srgbClr val="6B6A66"/>
+                </a:solidFill>
+                <a:latin typeface="Be Vietnam Pro" pitchFamily="34" charset="0"/>
+                <a:ea typeface="Be Vietnam Pro" pitchFamily="34" charset="-122"/>
+                <a:cs typeface="Be Vietnam Pro" pitchFamily="34" charset="-120"/>
+              </a:rPr>
               <a:t> nhất.</a:t>
             </a:r>
             <a:r>
-              <a:rPr lang="en-US" sz="1950" dirty="0" spc="1" kern="0">
+              <a:rPr lang="en-US" sz="1650" dirty="0" spc="0" kern="0">
                 <a:solidFill>
                   <a:srgbClr val="6B6A66"/>
                 </a:solidFill>
@@ -8827,7 +9047,7 @@
               <a:t> Màu</a:t>
             </a:r>
             <a:r>
-              <a:rPr lang="en-US" sz="1950" dirty="0" spc="-8" kern="0">
+              <a:rPr lang="en-US" sz="1650" dirty="0" spc="-5" kern="0">
                 <a:solidFill>
                   <a:srgbClr val="6B6A66"/>
                 </a:solidFill>
@@ -8838,7 +9058,7 @@
               <a:t> nhạt:</a:t>
             </a:r>
             <a:r>
-              <a:rPr lang="en-US" sz="1950" dirty="0" spc="-14" kern="0">
+              <a:rPr lang="en-US" sz="1650" dirty="0" spc="-9" kern="0">
                 <a:solidFill>
                   <a:srgbClr val="6B6A66"/>
                 </a:solidFill>
@@ -8849,7 +9069,7 @@
               <a:t> byte</a:t>
             </a:r>
             <a:r>
-              <a:rPr lang="en-US" sz="1950" dirty="0" spc="0" kern="0">
+              <a:rPr lang="en-US" sz="1650" dirty="0" spc="-10" kern="0">
                 <a:solidFill>
                   <a:srgbClr val="6B6A66"/>
                 </a:solidFill>
@@ -8857,10 +9077,10 @@
                 <a:ea typeface="Be Vietnam Pro" pitchFamily="34" charset="-122"/>
                 <a:cs typeface="Be Vietnam Pro" pitchFamily="34" charset="-120"/>
               </a:rPr>
-              <a:t> nhỏ</a:t>
-            </a:r>
-            <a:r>
-              <a:rPr lang="en-US" sz="1950" dirty="0" spc="-8" kern="0">
+              <a:t> trọng</a:t>
+            </a:r>
+            <a:r>
+              <a:rPr lang="en-US" sz="1650" dirty="0" spc="-4" kern="0">
                 <a:solidFill>
                   <a:srgbClr val="6B6A66"/>
                 </a:solidFill>
@@ -8868,9 +9088,31 @@
                 <a:ea typeface="Be Vietnam Pro" pitchFamily="34" charset="-122"/>
                 <a:cs typeface="Be Vietnam Pro" pitchFamily="34" charset="-120"/>
               </a:rPr>
+              <a:t> số</a:t>
+            </a:r>
+            <a:r>
+              <a:rPr lang="en-US" sz="1650" dirty="0" spc="3" kern="0">
+                <a:solidFill>
+                  <a:srgbClr val="6B6A66"/>
+                </a:solidFill>
+                <a:latin typeface="Be Vietnam Pro" pitchFamily="34" charset="0"/>
+                <a:ea typeface="Be Vietnam Pro" pitchFamily="34" charset="-122"/>
+                <a:cs typeface="Be Vietnam Pro" pitchFamily="34" charset="-120"/>
+              </a:rPr>
+              <a:t> thấp</a:t>
+            </a:r>
+            <a:r>
+              <a:rPr lang="en-US" sz="1650" dirty="0" spc="-5" kern="0">
+                <a:solidFill>
+                  <a:srgbClr val="6B6A66"/>
+                </a:solidFill>
+                <a:latin typeface="Be Vietnam Pro" pitchFamily="34" charset="0"/>
+                <a:ea typeface="Be Vietnam Pro" pitchFamily="34" charset="-122"/>
+                <a:cs typeface="Be Vietnam Pro" pitchFamily="34" charset="-120"/>
+              </a:rPr>
               <a:t> nhất.</a:t>
             </a:r>
-            <a:endParaRPr lang="en-US" sz="1950" dirty="0"/>
+            <a:endParaRPr lang="en-US" sz="1650" dirty="0"/>
           </a:p>
         </p:txBody>
       </p:sp>
@@ -9408,7 +9650,7 @@
               <a:t>Byte</a:t>
             </a:r>
             <a:r>
-              <a:rPr lang="en-US" sz="3300" b="1" dirty="0" spc="-7" kern="0">
+              <a:rPr lang="en-US" sz="3300" b="1" dirty="0" spc="-20" kern="0">
                 <a:solidFill>
                   <a:srgbClr val="7C93FF"/>
                 </a:solidFill>
@@ -9416,7 +9658,29 @@
                 <a:ea typeface="Be Vietnam Pro" pitchFamily="34" charset="-122"/>
                 <a:cs typeface="Be Vietnam Pro" pitchFamily="34" charset="-120"/>
               </a:rPr>
-              <a:t> lớn</a:t>
+              <a:t> trọng</a:t>
+            </a:r>
+            <a:r>
+              <a:rPr lang="en-US" sz="3300" b="1" dirty="0" spc="-8" kern="0">
+                <a:solidFill>
+                  <a:srgbClr val="7C93FF"/>
+                </a:solidFill>
+                <a:latin typeface="Be Vietnam Pro" pitchFamily="34" charset="0"/>
+                <a:ea typeface="Be Vietnam Pro" pitchFamily="34" charset="-122"/>
+                <a:cs typeface="Be Vietnam Pro" pitchFamily="34" charset="-120"/>
+              </a:rPr>
+              <a:t> số</a:t>
+            </a:r>
+            <a:r>
+              <a:rPr lang="en-US" sz="3300" b="1" dirty="0" spc="-3" kern="0">
+                <a:solidFill>
+                  <a:srgbClr val="7C93FF"/>
+                </a:solidFill>
+                <a:latin typeface="Be Vietnam Pro" pitchFamily="34" charset="0"/>
+                <a:ea typeface="Be Vietnam Pro" pitchFamily="34" charset="-122"/>
+                <a:cs typeface="Be Vietnam Pro" pitchFamily="34" charset="-120"/>
+              </a:rPr>
+              <a:t> cao</a:t>
             </a:r>
             <a:r>
               <a:rPr lang="en-US" sz="3300" b="1" dirty="0" spc="-12" kern="0">
@@ -9558,18 +9822,40 @@
               <a:t>byte</a:t>
             </a:r>
             <a:r>
-              <a:rPr lang="en-US" sz="2850" dirty="0" spc="0" kern="0">
-                <a:solidFill>
-                  <a:srgbClr val="F3EEE3"/>
-                </a:solidFill>
-                <a:latin typeface="Be Vietnam Pro" pitchFamily="34" charset="0"/>
-                <a:ea typeface="Be Vietnam Pro" pitchFamily="34" charset="-122"/>
-                <a:cs typeface="Be Vietnam Pro" pitchFamily="34" charset="-120"/>
-              </a:rPr>
-              <a:t> lớn</a:t>
-            </a:r>
-            <a:r>
-              <a:rPr lang="en-US" sz="2850" dirty="0" spc="-13" kern="0">
+              <a:rPr lang="en-US" sz="2850" dirty="0" spc="-20" kern="0">
+                <a:solidFill>
+                  <a:srgbClr val="F3EEE3"/>
+                </a:solidFill>
+                <a:latin typeface="Be Vietnam Pro" pitchFamily="34" charset="0"/>
+                <a:ea typeface="Be Vietnam Pro" pitchFamily="34" charset="-122"/>
+                <a:cs typeface="Be Vietnam Pro" pitchFamily="34" charset="-120"/>
+              </a:rPr>
+              <a:t> trọng</a:t>
+            </a:r>
+            <a:r>
+              <a:rPr lang="en-US" sz="2850" dirty="0" spc="-11" kern="0">
+                <a:solidFill>
+                  <a:srgbClr val="F3EEE3"/>
+                </a:solidFill>
+                <a:latin typeface="Be Vietnam Pro" pitchFamily="34" charset="0"/>
+                <a:ea typeface="Be Vietnam Pro" pitchFamily="34" charset="-122"/>
+                <a:cs typeface="Be Vietnam Pro" pitchFamily="34" charset="-120"/>
+              </a:rPr>
+              <a:t> số</a:t>
+            </a:r>
+            <a:r>
+              <a:rPr lang="en-US" sz="2850" dirty="0" spc="3" kern="0">
+                <a:solidFill>
+                  <a:srgbClr val="F3EEE3"/>
+                </a:solidFill>
+                <a:latin typeface="Be Vietnam Pro" pitchFamily="34" charset="0"/>
+                <a:ea typeface="Be Vietnam Pro" pitchFamily="34" charset="-122"/>
+                <a:cs typeface="Be Vietnam Pro" pitchFamily="34" charset="-120"/>
+              </a:rPr>
+              <a:t> cao</a:t>
+            </a:r>
+            <a:r>
+              <a:rPr lang="en-US" sz="2850" dirty="0" spc="-12" kern="0">
                 <a:solidFill>
                   <a:srgbClr val="F3EEE3"/>
                 </a:solidFill>
@@ -9900,62 +10186,84 @@
               <a:t>Byte</a:t>
             </a:r>
             <a:r>
-              <a:rPr lang="en-US" sz="2550" dirty="0" spc="-1" kern="0">
-                <a:solidFill>
-                  <a:srgbClr val="F3EEE3"/>
-                </a:solidFill>
-                <a:latin typeface="Be Vietnam Pro" pitchFamily="34" charset="0"/>
-                <a:ea typeface="Be Vietnam Pro" pitchFamily="34" charset="-122"/>
-                <a:cs typeface="Be Vietnam Pro" pitchFamily="34" charset="-120"/>
-              </a:rPr>
-              <a:t> lớn</a:t>
+              <a:rPr lang="en-US" sz="2550" dirty="0" spc="-17" kern="0">
+                <a:solidFill>
+                  <a:srgbClr val="F3EEE3"/>
+                </a:solidFill>
+                <a:latin typeface="Be Vietnam Pro" pitchFamily="34" charset="0"/>
+                <a:ea typeface="Be Vietnam Pro" pitchFamily="34" charset="-122"/>
+                <a:cs typeface="Be Vietnam Pro" pitchFamily="34" charset="-120"/>
+              </a:rPr>
+              <a:t> trọng</a:t>
+            </a:r>
+            <a:r>
+              <a:rPr lang="en-US" sz="2550" dirty="0" spc="-10" kern="0">
+                <a:solidFill>
+                  <a:srgbClr val="F3EEE3"/>
+                </a:solidFill>
+                <a:latin typeface="Be Vietnam Pro" pitchFamily="34" charset="0"/>
+                <a:ea typeface="Be Vietnam Pro" pitchFamily="34" charset="-122"/>
+                <a:cs typeface="Be Vietnam Pro" pitchFamily="34" charset="-120"/>
+              </a:rPr>
+              <a:t> số</a:t>
+            </a:r>
+            <a:r>
+              <a:rPr lang="en-US" sz="2550" dirty="0" spc="0" kern="0">
+                <a:solidFill>
+                  <a:srgbClr val="F3EEE3"/>
+                </a:solidFill>
+                <a:latin typeface="Be Vietnam Pro" pitchFamily="34" charset="0"/>
+                <a:ea typeface="Be Vietnam Pro" pitchFamily="34" charset="-122"/>
+                <a:cs typeface="Be Vietnam Pro" pitchFamily="34" charset="-120"/>
+              </a:rPr>
+              <a:t> cao</a:t>
+            </a:r>
+            <a:r>
+              <a:rPr lang="en-US" sz="2550" dirty="0" spc="-10" kern="0">
+                <a:solidFill>
+                  <a:srgbClr val="F3EEE3"/>
+                </a:solidFill>
+                <a:latin typeface="Be Vietnam Pro" pitchFamily="34" charset="0"/>
+                <a:ea typeface="Be Vietnam Pro" pitchFamily="34" charset="-122"/>
+                <a:cs typeface="Be Vietnam Pro" pitchFamily="34" charset="-120"/>
+              </a:rPr>
+              <a:t> nhất</a:t>
+            </a:r>
+            <a:r>
+              <a:rPr lang="en-US" sz="2550" dirty="0" spc="0" kern="0">
+                <a:solidFill>
+                  <a:srgbClr val="F3EEE3"/>
+                </a:solidFill>
+                <a:latin typeface="Be Vietnam Pro" pitchFamily="34" charset="0"/>
+                <a:ea typeface="Be Vietnam Pro" pitchFamily="34" charset="-122"/>
+                <a:cs typeface="Be Vietnam Pro" pitchFamily="34" charset="-120"/>
+              </a:rPr>
+              <a:t> ở</a:t>
+            </a:r>
+            <a:r>
+              <a:rPr lang="en-US" sz="2550" dirty="0" spc="26" kern="0">
+                <a:solidFill>
+                  <a:srgbClr val="F3EEE3"/>
+                </a:solidFill>
+                <a:latin typeface="Be Vietnam Pro" pitchFamily="34" charset="0"/>
+                <a:ea typeface="Be Vietnam Pro" pitchFamily="34" charset="-122"/>
+                <a:cs typeface="Be Vietnam Pro" pitchFamily="34" charset="-120"/>
+              </a:rPr>
+              <a:t> địa</a:t>
+            </a:r>
+            <a:r>
+              <a:rPr lang="en-US" sz="2550" dirty="0" spc="1" kern="0">
+                <a:solidFill>
+                  <a:srgbClr val="F3EEE3"/>
+                </a:solidFill>
+                <a:latin typeface="Be Vietnam Pro" pitchFamily="34" charset="0"/>
+                <a:ea typeface="Be Vietnam Pro" pitchFamily="34" charset="-122"/>
+                <a:cs typeface="Be Vietnam Pro" pitchFamily="34" charset="-120"/>
+              </a:rPr>
+              <a:t> chỉ thấp</a:t>
             </a:r>
             <a:r>
               <a:rPr lang="en-US" sz="2550" dirty="0" spc="-9" kern="0">
-                <a:solidFill>
-                  <a:srgbClr val="F3EEE3"/>
-                </a:solidFill>
-                <a:latin typeface="Be Vietnam Pro" pitchFamily="34" charset="0"/>
-                <a:ea typeface="Be Vietnam Pro" pitchFamily="34" charset="-122"/>
-                <a:cs typeface="Be Vietnam Pro" pitchFamily="34" charset="-120"/>
-              </a:rPr>
-              <a:t> nhất</a:t>
-            </a:r>
-            <a:r>
-              <a:rPr lang="en-US" sz="2550" dirty="0" spc="-2" kern="0">
-                <a:solidFill>
-                  <a:srgbClr val="F3EEE3"/>
-                </a:solidFill>
-                <a:latin typeface="Be Vietnam Pro" pitchFamily="34" charset="0"/>
-                <a:ea typeface="Be Vietnam Pro" pitchFamily="34" charset="-122"/>
-                <a:cs typeface="Be Vietnam Pro" pitchFamily="34" charset="-120"/>
-              </a:rPr>
-              <a:t> ở</a:t>
-            </a:r>
-            <a:r>
-              <a:rPr lang="en-US" sz="2550" dirty="0" spc="26" kern="0">
-                <a:solidFill>
-                  <a:srgbClr val="F3EEE3"/>
-                </a:solidFill>
-                <a:latin typeface="Be Vietnam Pro" pitchFamily="34" charset="0"/>
-                <a:ea typeface="Be Vietnam Pro" pitchFamily="34" charset="-122"/>
-                <a:cs typeface="Be Vietnam Pro" pitchFamily="34" charset="-120"/>
-              </a:rPr>
-              <a:t> địa</a:t>
-            </a:r>
-            <a:r>
-              <a:rPr lang="en-US" sz="2550" dirty="0" spc="1" kern="0">
-                <a:solidFill>
-                  <a:srgbClr val="F3EEE3"/>
-                </a:solidFill>
-                <a:latin typeface="Be Vietnam Pro" pitchFamily="34" charset="0"/>
-                <a:ea typeface="Be Vietnam Pro" pitchFamily="34" charset="-122"/>
-                <a:cs typeface="Be Vietnam Pro" pitchFamily="34" charset="-120"/>
-              </a:rPr>
-              <a:t> chỉ thấp</a:t>
-            </a:r>
-            <a:r>
-              <a:rPr lang="en-US" sz="2550" dirty="0" spc="-10" kern="0">
                 <a:solidFill>
                   <a:srgbClr val="F3EEE3"/>
                 </a:solidFill>
@@ -9988,15 +10296,15 @@
               <a:t>Byte</a:t>
             </a:r>
             <a:r>
-              <a:rPr lang="en-US" sz="2550" dirty="0" spc="-1" kern="0">
-                <a:solidFill>
-                  <a:srgbClr val="F3EEE3"/>
-                </a:solidFill>
-                <a:latin typeface="Be Vietnam Pro" pitchFamily="34" charset="0"/>
-                <a:ea typeface="Be Vietnam Pro" pitchFamily="34" charset="-122"/>
-                <a:cs typeface="Be Vietnam Pro" pitchFamily="34" charset="-120"/>
-              </a:rPr>
-              <a:t> nhỏ</a:t>
+              <a:rPr lang="en-US" sz="2550" dirty="0" spc="-17" kern="0">
+                <a:solidFill>
+                  <a:srgbClr val="F3EEE3"/>
+                </a:solidFill>
+                <a:latin typeface="Be Vietnam Pro" pitchFamily="34" charset="0"/>
+                <a:ea typeface="Be Vietnam Pro" pitchFamily="34" charset="-122"/>
+                <a:cs typeface="Be Vietnam Pro" pitchFamily="34" charset="-120"/>
+              </a:rPr>
+              <a:t> trọng</a:t>
             </a:r>
             <a:r>
               <a:rPr lang="en-US" sz="2550" dirty="0" spc="-10" kern="0">
@@ -10007,10 +10315,32 @@
                 <a:ea typeface="Be Vietnam Pro" pitchFamily="34" charset="-122"/>
                 <a:cs typeface="Be Vietnam Pro" pitchFamily="34" charset="-120"/>
               </a:rPr>
+              <a:t> số</a:t>
+            </a:r>
+            <a:r>
+              <a:rPr lang="en-US" sz="2550" dirty="0" spc="1" kern="0">
+                <a:solidFill>
+                  <a:srgbClr val="F3EEE3"/>
+                </a:solidFill>
+                <a:latin typeface="Be Vietnam Pro" pitchFamily="34" charset="0"/>
+                <a:ea typeface="Be Vietnam Pro" pitchFamily="34" charset="-122"/>
+                <a:cs typeface="Be Vietnam Pro" pitchFamily="34" charset="-120"/>
+              </a:rPr>
+              <a:t> thấp</a:t>
+            </a:r>
+            <a:r>
+              <a:rPr lang="en-US" sz="2550" dirty="0" spc="-9" kern="0">
+                <a:solidFill>
+                  <a:srgbClr val="F3EEE3"/>
+                </a:solidFill>
+                <a:latin typeface="Be Vietnam Pro" pitchFamily="34" charset="0"/>
+                <a:ea typeface="Be Vietnam Pro" pitchFamily="34" charset="-122"/>
+                <a:cs typeface="Be Vietnam Pro" pitchFamily="34" charset="-120"/>
+              </a:rPr>
               <a:t> nhất</a:t>
             </a:r>
             <a:r>
-              <a:rPr lang="en-US" sz="2550" dirty="0" spc="0" kern="0">
+              <a:rPr lang="en-US" sz="2550" dirty="0" spc="-2" kern="0">
                 <a:solidFill>
                   <a:srgbClr val="F3EEE3"/>
                 </a:solidFill>
@@ -10330,7 +10660,7 @@
               <a:buNone/>
             </a:pPr>
             <a:r>
-              <a:rPr lang="en-US" sz="2550" b="1" dirty="0" spc="-13" kern="0">
+              <a:rPr lang="en-US" sz="2100" b="1" dirty="0" spc="-12" kern="0">
                 <a:solidFill>
                   <a:srgbClr val="7C93FF"/>
                 </a:solidFill>
@@ -10341,7 +10671,7 @@
               <a:t>byte</a:t>
             </a:r>
             <a:r>
-              <a:rPr lang="en-US" sz="2550" b="1" dirty="0" spc="-4" kern="0">
+              <a:rPr lang="en-US" sz="2100" b="1" dirty="0" spc="-14" kern="0">
                 <a:solidFill>
                   <a:srgbClr val="7C93FF"/>
                 </a:solidFill>
@@ -10349,10 +10679,10 @@
                 <a:ea typeface="Be Vietnam Pro" pitchFamily="34" charset="-122"/>
                 <a:cs typeface="Be Vietnam Pro" pitchFamily="34" charset="-120"/>
               </a:rPr>
-              <a:t> lớn</a:t>
-            </a:r>
-            <a:r>
-              <a:rPr lang="en-US" sz="2550" b="1" dirty="0" spc="-6" kern="0">
+              <a:t> trọng</a:t>
+            </a:r>
+            <a:r>
+              <a:rPr lang="en-US" sz="2100" b="1" dirty="0" spc="-6" kern="0">
                 <a:solidFill>
                   <a:srgbClr val="7C93FF"/>
                 </a:solidFill>
@@ -10360,9 +10690,20 @@
                 <a:ea typeface="Be Vietnam Pro" pitchFamily="34" charset="-122"/>
                 <a:cs typeface="Be Vietnam Pro" pitchFamily="34" charset="-120"/>
               </a:rPr>
-              <a:t> nhất</a:t>
-            </a:r>
-            <a:endParaRPr lang="en-US" sz="2550" dirty="0"/>
+              <a:t> số</a:t>
+            </a:r>
+            <a:r>
+              <a:rPr lang="en-US" sz="2100" b="1" dirty="0" spc="-5" kern="0">
+                <a:solidFill>
+                  <a:srgbClr val="7C93FF"/>
+                </a:solidFill>
+                <a:latin typeface="Be Vietnam Pro" pitchFamily="34" charset="0"/>
+                <a:ea typeface="Be Vietnam Pro" pitchFamily="34" charset="-122"/>
+                <a:cs typeface="Be Vietnam Pro" pitchFamily="34" charset="-120"/>
+              </a:rPr>
+              <a:t> cao nhất</a:t>
+            </a:r>
+            <a:endParaRPr lang="en-US" sz="2100" dirty="0"/>
           </a:p>
         </p:txBody>
       </p:sp>
@@ -10391,7 +10732,7 @@
               <a:buNone/>
             </a:pPr>
             <a:r>
-              <a:rPr lang="en-US" sz="2550" b="1" dirty="0" spc="-13" kern="0">
+              <a:rPr lang="en-US" sz="2025" b="1" dirty="0" spc="-12" kern="0">
                 <a:solidFill>
                   <a:srgbClr val="7C93FF"/>
                 </a:solidFill>
@@ -10402,7 +10743,7 @@
               <a:t>byte</a:t>
             </a:r>
             <a:r>
-              <a:rPr lang="en-US" sz="2550" b="1" dirty="0" spc="-3" kern="0">
+              <a:rPr lang="en-US" sz="2025" b="1" dirty="0" spc="-11" kern="0">
                 <a:solidFill>
                   <a:srgbClr val="7C93FF"/>
                 </a:solidFill>
@@ -10410,10 +10751,10 @@
                 <a:ea typeface="Be Vietnam Pro" pitchFamily="34" charset="-122"/>
                 <a:cs typeface="Be Vietnam Pro" pitchFamily="34" charset="-120"/>
               </a:rPr>
-              <a:t> nhỏ</a:t>
-            </a:r>
-            <a:r>
-              <a:rPr lang="en-US" sz="2550" b="1" dirty="0" spc="-6" kern="0">
+              <a:t> trọng</a:t>
+            </a:r>
+            <a:r>
+              <a:rPr lang="en-US" sz="2025" b="1" dirty="0" spc="-4" kern="0">
                 <a:solidFill>
                   <a:srgbClr val="7C93FF"/>
                 </a:solidFill>
@@ -10421,9 +10762,31 @@
                 <a:ea typeface="Be Vietnam Pro" pitchFamily="34" charset="-122"/>
                 <a:cs typeface="Be Vietnam Pro" pitchFamily="34" charset="-120"/>
               </a:rPr>
+              <a:t> số</a:t>
+            </a:r>
+            <a:r>
+              <a:rPr lang="en-US" sz="2025" b="1" dirty="0" spc="2" kern="0">
+                <a:solidFill>
+                  <a:srgbClr val="7C93FF"/>
+                </a:solidFill>
+                <a:latin typeface="Be Vietnam Pro" pitchFamily="34" charset="0"/>
+                <a:ea typeface="Be Vietnam Pro" pitchFamily="34" charset="-122"/>
+                <a:cs typeface="Be Vietnam Pro" pitchFamily="34" charset="-120"/>
+              </a:rPr>
+              <a:t> thấp</a:t>
+            </a:r>
+            <a:r>
+              <a:rPr lang="en-US" sz="2025" b="1" dirty="0" spc="-3" kern="0">
+                <a:solidFill>
+                  <a:srgbClr val="7C93FF"/>
+                </a:solidFill>
+                <a:latin typeface="Be Vietnam Pro" pitchFamily="34" charset="0"/>
+                <a:ea typeface="Be Vietnam Pro" pitchFamily="34" charset="-122"/>
+                <a:cs typeface="Be Vietnam Pro" pitchFamily="34" charset="-120"/>
+              </a:rPr>
               <a:t> nhất</a:t>
             </a:r>
-            <a:endParaRPr lang="en-US" sz="2550" dirty="0"/>
+            <a:endParaRPr lang="en-US" sz="2025" dirty="0"/>
           </a:p>
         </p:txBody>
       </p:sp>
@@ -10610,7 +10973,7 @@
               <a:buNone/>
             </a:pPr>
             <a:r>
-              <a:rPr lang="en-US" sz="1950" dirty="0" spc="1" kern="0">
+              <a:rPr lang="en-US" sz="1650" dirty="0" spc="-2" kern="0">
                 <a:solidFill>
                   <a:srgbClr val="9AA0B5"/>
                 </a:solidFill>
@@ -10621,7 +10984,7 @@
               <a:t>Màu</a:t>
             </a:r>
             <a:r>
-              <a:rPr lang="en-US" sz="1950" dirty="0" spc="8" kern="0">
+              <a:rPr lang="en-US" sz="1650" dirty="0" spc="8" kern="0">
                 <a:solidFill>
                   <a:srgbClr val="9AA0B5"/>
                 </a:solidFill>
@@ -10632,7 +10995,7 @@
               <a:t> đậm:</a:t>
             </a:r>
             <a:r>
-              <a:rPr lang="en-US" sz="1950" dirty="0" spc="-15" kern="0">
+              <a:rPr lang="en-US" sz="1650" dirty="0" spc="-9" kern="0">
                 <a:solidFill>
                   <a:srgbClr val="9AA0B5"/>
                 </a:solidFill>
@@ -10643,7 +11006,7 @@
               <a:t> byte</a:t>
             </a:r>
             <a:r>
-              <a:rPr lang="en-US" sz="1950" dirty="0" spc="0" kern="0">
+              <a:rPr lang="en-US" sz="1650" dirty="0" spc="-11" kern="0">
                 <a:solidFill>
                   <a:srgbClr val="9AA0B5"/>
                 </a:solidFill>
@@ -10651,10 +11014,10 @@
                 <a:ea typeface="Be Vietnam Pro" pitchFamily="34" charset="-122"/>
                 <a:cs typeface="Be Vietnam Pro" pitchFamily="34" charset="-120"/>
               </a:rPr>
-              <a:t> lớn</a:t>
-            </a:r>
-            <a:r>
-              <a:rPr lang="en-US" sz="1950" dirty="0" spc="-8" kern="0">
+              <a:t> trọng</a:t>
+            </a:r>
+            <a:r>
+              <a:rPr lang="en-US" sz="1650" dirty="0" spc="-3" kern="0">
                 <a:solidFill>
                   <a:srgbClr val="9AA0B5"/>
                 </a:solidFill>
@@ -10662,10 +11025,32 @@
                 <a:ea typeface="Be Vietnam Pro" pitchFamily="34" charset="-122"/>
                 <a:cs typeface="Be Vietnam Pro" pitchFamily="34" charset="-120"/>
               </a:rPr>
+              <a:t> số</a:t>
+            </a:r>
+            <a:r>
+              <a:rPr lang="en-US" sz="1650" dirty="0" spc="-1" kern="0">
+                <a:solidFill>
+                  <a:srgbClr val="9AA0B5"/>
+                </a:solidFill>
+                <a:latin typeface="Be Vietnam Pro" pitchFamily="34" charset="0"/>
+                <a:ea typeface="Be Vietnam Pro" pitchFamily="34" charset="-122"/>
+                <a:cs typeface="Be Vietnam Pro" pitchFamily="34" charset="-120"/>
+              </a:rPr>
+              <a:t> cao</a:t>
+            </a:r>
+            <a:r>
+              <a:rPr lang="en-US" sz="1650" dirty="0" spc="-5" kern="0">
+                <a:solidFill>
+                  <a:srgbClr val="9AA0B5"/>
+                </a:solidFill>
+                <a:latin typeface="Be Vietnam Pro" pitchFamily="34" charset="0"/>
+                <a:ea typeface="Be Vietnam Pro" pitchFamily="34" charset="-122"/>
+                <a:cs typeface="Be Vietnam Pro" pitchFamily="34" charset="-120"/>
+              </a:rPr>
               <a:t> nhất.</a:t>
             </a:r>
             <a:r>
-              <a:rPr lang="en-US" sz="1950" dirty="0" spc="1" kern="0">
+              <a:rPr lang="en-US" sz="1650" dirty="0" spc="0" kern="0">
                 <a:solidFill>
                   <a:srgbClr val="9AA0B5"/>
                 </a:solidFill>
@@ -10676,7 +11061,7 @@
               <a:t> Màu</a:t>
             </a:r>
             <a:r>
-              <a:rPr lang="en-US" sz="1950" dirty="0" spc="-8" kern="0">
+              <a:rPr lang="en-US" sz="1650" dirty="0" spc="-5" kern="0">
                 <a:solidFill>
                   <a:srgbClr val="9AA0B5"/>
                 </a:solidFill>
@@ -10687,7 +11072,7 @@
               <a:t> nhạt:</a:t>
             </a:r>
             <a:r>
-              <a:rPr lang="en-US" sz="1950" dirty="0" spc="-14" kern="0">
+              <a:rPr lang="en-US" sz="1650" dirty="0" spc="-9" kern="0">
                 <a:solidFill>
                   <a:srgbClr val="9AA0B5"/>
                 </a:solidFill>
@@ -10698,7 +11083,7 @@
               <a:t> byte</a:t>
             </a:r>
             <a:r>
-              <a:rPr lang="en-US" sz="1950" dirty="0" spc="0" kern="0">
+              <a:rPr lang="en-US" sz="1650" dirty="0" spc="-10" kern="0">
                 <a:solidFill>
                   <a:srgbClr val="9AA0B5"/>
                 </a:solidFill>
@@ -10706,10 +11091,10 @@
                 <a:ea typeface="Be Vietnam Pro" pitchFamily="34" charset="-122"/>
                 <a:cs typeface="Be Vietnam Pro" pitchFamily="34" charset="-120"/>
               </a:rPr>
-              <a:t> nhỏ</a:t>
-            </a:r>
-            <a:r>
-              <a:rPr lang="en-US" sz="1950" dirty="0" spc="-8" kern="0">
+              <a:t> trọng</a:t>
+            </a:r>
+            <a:r>
+              <a:rPr lang="en-US" sz="1650" dirty="0" spc="-4" kern="0">
                 <a:solidFill>
                   <a:srgbClr val="9AA0B5"/>
                 </a:solidFill>
@@ -10717,9 +11102,31 @@
                 <a:ea typeface="Be Vietnam Pro" pitchFamily="34" charset="-122"/>
                 <a:cs typeface="Be Vietnam Pro" pitchFamily="34" charset="-120"/>
               </a:rPr>
+              <a:t> số</a:t>
+            </a:r>
+            <a:r>
+              <a:rPr lang="en-US" sz="1650" dirty="0" spc="3" kern="0">
+                <a:solidFill>
+                  <a:srgbClr val="9AA0B5"/>
+                </a:solidFill>
+                <a:latin typeface="Be Vietnam Pro" pitchFamily="34" charset="0"/>
+                <a:ea typeface="Be Vietnam Pro" pitchFamily="34" charset="-122"/>
+                <a:cs typeface="Be Vietnam Pro" pitchFamily="34" charset="-120"/>
+              </a:rPr>
+              <a:t> thấp</a:t>
+            </a:r>
+            <a:r>
+              <a:rPr lang="en-US" sz="1650" dirty="0" spc="-5" kern="0">
+                <a:solidFill>
+                  <a:srgbClr val="9AA0B5"/>
+                </a:solidFill>
+                <a:latin typeface="Be Vietnam Pro" pitchFamily="34" charset="0"/>
+                <a:ea typeface="Be Vietnam Pro" pitchFamily="34" charset="-122"/>
+                <a:cs typeface="Be Vietnam Pro" pitchFamily="34" charset="-120"/>
+              </a:rPr>
               <a:t> nhất.</a:t>
             </a:r>
-            <a:endParaRPr lang="en-US" sz="1950" dirty="0"/>
+            <a:endParaRPr lang="en-US" sz="1650" dirty="0"/>
           </a:p>
         </p:txBody>
       </p:sp>
@@ -16009,17 +16416,17 @@
           <a:ln/>
         </p:spPr>
         <p:txBody>
-          <a:bodyPr wrap="square" lIns="0" tIns="12954" rIns="0" bIns="-12954" rtlCol="0" anchor="ctr"/>
+          <a:bodyPr wrap="square" lIns="0" tIns="12533" rIns="0" bIns="-12533" rtlCol="0" anchor="ctr"/>
           <a:lstStyle/>
           <a:p>
             <a:pPr algn="l" indent="0" marL="0">
               <a:lnSpc>
-                <a:spcPts val="3120"/>
+                <a:spcPts val="3023"/>
               </a:lnSpc>
               <a:buNone/>
             </a:pPr>
             <a:r>
-              <a:rPr lang="en-US" sz="2400" b="1" dirty="0" spc="-13" kern="0">
+              <a:rPr lang="en-US" sz="2325" b="1" dirty="0" spc="-12" kern="0">
                 <a:solidFill>
                   <a:srgbClr val="14161C"/>
                 </a:solidFill>
@@ -16030,29 +16437,18 @@
               <a:t>Máy</a:t>
             </a:r>
             <a:r>
-              <a:rPr lang="en-US" sz="2400" b="1" dirty="0" spc="0" kern="0">
-                <a:solidFill>
-                  <a:srgbClr val="14161C"/>
-                </a:solidFill>
-                <a:latin typeface="Be Vietnam Pro" pitchFamily="34" charset="0"/>
-                <a:ea typeface="Be Vietnam Pro" pitchFamily="34" charset="-122"/>
-                <a:cs typeface="Be Vietnam Pro" pitchFamily="34" charset="-120"/>
-              </a:rPr>
-              <a:t> big</a:t>
-            </a:r>
-            <a:r>
-              <a:rPr lang="en-US" sz="2400" b="1" dirty="0" spc="-4" kern="0">
-                <a:solidFill>
-                  <a:srgbClr val="14161C"/>
-                </a:solidFill>
-                <a:latin typeface="Be Vietnam Pro" pitchFamily="34" charset="0"/>
-                <a:ea typeface="Be Vietnam Pro" pitchFamily="34" charset="-122"/>
-                <a:cs typeface="Be Vietnam Pro" pitchFamily="34" charset="-120"/>
-              </a:rPr>
-              <a:t> endian</a:t>
-            </a:r>
-            <a:r>
-              <a:rPr lang="en-US" sz="2400" b="1" dirty="0" spc="-3" kern="0">
+              <a:rPr lang="en-US" sz="2325" b="1" dirty="0" spc="-1" kern="0">
+                <a:solidFill>
+                  <a:srgbClr val="14161C"/>
+                </a:solidFill>
+                <a:latin typeface="Be Vietnam Pro" pitchFamily="34" charset="0"/>
+                <a:ea typeface="Be Vietnam Pro" pitchFamily="34" charset="-122"/>
+                <a:cs typeface="Be Vietnam Pro" pitchFamily="34" charset="-120"/>
+              </a:rPr>
+              <a:t> big endian</a:t>
+            </a:r>
+            <a:r>
+              <a:rPr lang="en-US" sz="2325" b="1" dirty="0" spc="-3" kern="0">
                 <a:solidFill>
                   <a:srgbClr val="14161C"/>
                 </a:solidFill>
@@ -16063,7 +16459,7 @@
               <a:t> coi</a:t>
             </a:r>
             <a:r>
-              <a:rPr lang="en-US" sz="2400" b="1" dirty="0" spc="-11" kern="0">
+              <a:rPr lang="en-US" sz="2325" b="1" dirty="0" spc="-10" kern="0">
                 <a:solidFill>
                   <a:srgbClr val="14161C"/>
                 </a:solidFill>
@@ -16074,7 +16470,7 @@
               <a:t> byte</a:t>
             </a:r>
             <a:r>
-              <a:rPr lang="en-US" sz="2400" b="1" dirty="0" spc="10" kern="0">
+              <a:rPr lang="en-US" sz="2325" b="1" dirty="0" spc="11" kern="0">
                 <a:solidFill>
                   <a:srgbClr val="14161C"/>
                 </a:solidFill>
@@ -16085,7 +16481,7 @@
               <a:t> đầu</a:t>
             </a:r>
             <a:r>
-              <a:rPr lang="en-US" sz="2400" b="1" dirty="0" spc="-1" kern="0">
+              <a:rPr lang="en-US" sz="2325" b="1" dirty="0" spc="-7" kern="0">
                 <a:solidFill>
                   <a:srgbClr val="14161C"/>
                 </a:solidFill>
@@ -16096,7 +16492,7 @@
               <a:t> là</a:t>
             </a:r>
             <a:r>
-              <a:rPr lang="en-US" sz="2400" b="1" dirty="0" spc="-12" kern="0">
+              <a:rPr lang="en-US" sz="2325" b="1" dirty="0" spc="-9" kern="0">
                 <a:solidFill>
                   <a:srgbClr val="14161C"/>
                 </a:solidFill>
@@ -16107,18 +16503,40 @@
               <a:t> byte</a:t>
             </a:r>
             <a:r>
-              <a:rPr lang="en-US" sz="2400" b="1" dirty="0" spc="-1" kern="0">
-                <a:solidFill>
-                  <a:srgbClr val="14161C"/>
-                </a:solidFill>
-                <a:latin typeface="Be Vietnam Pro" pitchFamily="34" charset="0"/>
-                <a:ea typeface="Be Vietnam Pro" pitchFamily="34" charset="-122"/>
-                <a:cs typeface="Be Vietnam Pro" pitchFamily="34" charset="-120"/>
-              </a:rPr>
-              <a:t> lớn</a:t>
-            </a:r>
-            <a:r>
-              <a:rPr lang="en-US" sz="2400" b="1" dirty="0" spc="-7" kern="0">
+              <a:rPr lang="en-US" sz="2325" b="1" dirty="0" spc="-13" kern="0">
+                <a:solidFill>
+                  <a:srgbClr val="14161C"/>
+                </a:solidFill>
+                <a:latin typeface="Be Vietnam Pro" pitchFamily="34" charset="0"/>
+                <a:ea typeface="Be Vietnam Pro" pitchFamily="34" charset="-122"/>
+                <a:cs typeface="Be Vietnam Pro" pitchFamily="34" charset="-120"/>
+              </a:rPr>
+              <a:t> trọng</a:t>
+            </a:r>
+            <a:r>
+              <a:rPr lang="en-US" sz="2325" b="1" dirty="0" spc="-3" kern="0">
+                <a:solidFill>
+                  <a:srgbClr val="14161C"/>
+                </a:solidFill>
+                <a:latin typeface="Be Vietnam Pro" pitchFamily="34" charset="0"/>
+                <a:ea typeface="Be Vietnam Pro" pitchFamily="34" charset="-122"/>
+                <a:cs typeface="Be Vietnam Pro" pitchFamily="34" charset="-120"/>
+              </a:rPr>
+              <a:t> số</a:t>
+            </a:r>
+            <a:r>
+              <a:rPr lang="en-US" sz="2325" b="1" dirty="0" spc="2" kern="0">
+                <a:solidFill>
+                  <a:srgbClr val="14161C"/>
+                </a:solidFill>
+                <a:latin typeface="Be Vietnam Pro" pitchFamily="34" charset="0"/>
+                <a:ea typeface="Be Vietnam Pro" pitchFamily="34" charset="-122"/>
+                <a:cs typeface="Be Vietnam Pro" pitchFamily="34" charset="-120"/>
+              </a:rPr>
+              <a:t> cao</a:t>
+            </a:r>
+            <a:r>
+              <a:rPr lang="en-US" sz="2325" b="1" dirty="0" spc="-4" kern="0">
                 <a:solidFill>
                   <a:srgbClr val="14161C"/>
                 </a:solidFill>
@@ -16128,7 +16546,7 @@
               </a:rPr>
               <a:t> nhất</a:t>
             </a:r>
-            <a:endParaRPr lang="en-US" sz="2400" dirty="0"/>
+            <a:endParaRPr lang="en-US" sz="2325" dirty="0"/>
           </a:p>
         </p:txBody>
       </p:sp>
@@ -17219,7 +17637,7 @@
               <a:t>byte</a:t>
             </a:r>
             <a:r>
-              <a:rPr lang="en-US" sz="3600" dirty="0" spc="-21" kern="0">
+              <a:rPr lang="en-US" sz="3600" dirty="0" spc="-6" kern="0">
                 <a:solidFill>
                   <a:srgbClr val="3DD6A0"/>
                 </a:solidFill>
@@ -17227,7 +17645,29 @@
                 <a:ea typeface="Bricolage Grotesque ExtraBold" pitchFamily="34" charset="-122"/>
                 <a:cs typeface="Bricolage Grotesque ExtraBold" pitchFamily="34" charset="-120"/>
               </a:rPr>
-              <a:t> lớn</a:t>
+              <a:t> trọng</a:t>
+            </a:r>
+            <a:r>
+              <a:rPr lang="en-US" sz="3600" dirty="0" spc="4" kern="0">
+                <a:solidFill>
+                  <a:srgbClr val="3DD6A0"/>
+                </a:solidFill>
+                <a:latin typeface="Bricolage Grotesque ExtraBold" pitchFamily="34" charset="0"/>
+                <a:ea typeface="Bricolage Grotesque ExtraBold" pitchFamily="34" charset="-122"/>
+                <a:cs typeface="Bricolage Grotesque ExtraBold" pitchFamily="34" charset="-120"/>
+              </a:rPr>
+              <a:t> số</a:t>
+            </a:r>
+            <a:r>
+              <a:rPr lang="en-US" sz="3600" dirty="0" spc="5" kern="0">
+                <a:solidFill>
+                  <a:srgbClr val="3DD6A0"/>
+                </a:solidFill>
+                <a:latin typeface="Bricolage Grotesque ExtraBold" pitchFamily="34" charset="0"/>
+                <a:ea typeface="Bricolage Grotesque ExtraBold" pitchFamily="34" charset="-122"/>
+                <a:cs typeface="Bricolage Grotesque ExtraBold" pitchFamily="34" charset="-120"/>
+              </a:rPr>
+              <a:t> cao</a:t>
             </a:r>
             <a:r>
               <a:rPr lang="en-US" sz="3600" dirty="0" spc="1" kern="0">
@@ -17492,7 +17932,7 @@
               <a:buNone/>
             </a:pPr>
             <a:r>
-              <a:rPr lang="en-US" sz="3600" dirty="0" spc="-12" kern="0">
+              <a:rPr lang="en-US" sz="3525" dirty="0" spc="-9" kern="0">
                 <a:solidFill>
                   <a:srgbClr val="3DD6A0"/>
                 </a:solidFill>
@@ -17503,7 +17943,7 @@
               <a:t>byte</a:t>
             </a:r>
             <a:r>
-              <a:rPr lang="en-US" sz="3600" dirty="0" spc="1" kern="0">
+              <a:rPr lang="en-US" sz="3525" dirty="0" spc="-7" kern="0">
                 <a:solidFill>
                   <a:srgbClr val="3DD6A0"/>
                 </a:solidFill>
@@ -17511,9 +17951,42 @@
                 <a:ea typeface="Bricolage Grotesque ExtraBold" pitchFamily="34" charset="-122"/>
                 <a:cs typeface="Bricolage Grotesque ExtraBold" pitchFamily="34" charset="-120"/>
               </a:rPr>
-              <a:t> nhỏ nhất</a:t>
-            </a:r>
-            <a:endParaRPr lang="en-US" sz="3600" dirty="0"/>
+              <a:t> trọng</a:t>
+            </a:r>
+            <a:r>
+              <a:rPr lang="en-US" sz="3525" dirty="0" spc="-1" kern="0">
+                <a:solidFill>
+                  <a:srgbClr val="3DD6A0"/>
+                </a:solidFill>
+                <a:latin typeface="Bricolage Grotesque ExtraBold" pitchFamily="34" charset="0"/>
+                <a:ea typeface="Bricolage Grotesque ExtraBold" pitchFamily="34" charset="-122"/>
+                <a:cs typeface="Bricolage Grotesque ExtraBold" pitchFamily="34" charset="-120"/>
+              </a:rPr>
+              <a:t> số</a:t>
+            </a:r>
+            <a:r>
+              <a:rPr lang="en-US" sz="3525" dirty="0" spc="1" kern="0">
+                <a:solidFill>
+                  <a:srgbClr val="3DD6A0"/>
+                </a:solidFill>
+                <a:latin typeface="Bricolage Grotesque ExtraBold" pitchFamily="34" charset="0"/>
+                <a:ea typeface="Bricolage Grotesque ExtraBold" pitchFamily="34" charset="-122"/>
+                <a:cs typeface="Bricolage Grotesque ExtraBold" pitchFamily="34" charset="-120"/>
+              </a:rPr>
+              <a:t> thấp</a:t>
+            </a:r>
+            <a:r>
+              <a:rPr lang="en-US" sz="3525" dirty="0" spc="3" kern="0">
+                <a:solidFill>
+                  <a:srgbClr val="3DD6A0"/>
+                </a:solidFill>
+                <a:latin typeface="Bricolage Grotesque ExtraBold" pitchFamily="34" charset="0"/>
+                <a:ea typeface="Bricolage Grotesque ExtraBold" pitchFamily="34" charset="-122"/>
+                <a:cs typeface="Bricolage Grotesque ExtraBold" pitchFamily="34" charset="-120"/>
+              </a:rPr>
+              <a:t> nhất</a:t>
+            </a:r>
+            <a:endParaRPr lang="en-US" sz="3525" dirty="0"/>
           </a:p>
         </p:txBody>
       </p:sp>
@@ -17924,12 +18397,12 @@
           <a:ln/>
         </p:spPr>
         <p:txBody>
-          <a:bodyPr wrap="square" lIns="0" tIns="5334" rIns="0" bIns="-5334" rtlCol="0" anchor="t"/>
+          <a:bodyPr wrap="square" lIns="0" tIns="4667" rIns="0" bIns="-4667" rtlCol="0" anchor="t"/>
           <a:lstStyle/>
           <a:p>
-            <a:pPr algn="l" marL="304800" indent="-217761">
+            <a:pPr algn="l" marL="266700" indent="-190541">
               <a:lnSpc>
-                <a:spcPts val="3360"/>
+                <a:spcPts val="2940"/>
               </a:lnSpc>
               <a:spcAft>
                 <a:spcPts val="1050"/>
@@ -17939,7 +18412,7 @@
               <a:buChar char="•"/>
             </a:pPr>
             <a:r>
-              <a:rPr lang="en-US" sz="2400" dirty="0" spc="2" kern="0">
+              <a:rPr lang="en-US" sz="2100" dirty="0" spc="3" kern="0">
                 <a:solidFill>
                   <a:srgbClr val="F3EEE3"/>
                 </a:solidFill>
@@ -17950,7 +18423,7 @@
               <a:t>Big</a:t>
             </a:r>
             <a:r>
-              <a:rPr lang="en-US" sz="2400" dirty="0" spc="0" kern="0">
+              <a:rPr lang="en-US" sz="2100" dirty="0" spc="-1" kern="0">
                 <a:solidFill>
                   <a:srgbClr val="F3EEE3"/>
                 </a:solidFill>
@@ -17961,7 +18434,7 @@
               <a:t> endian:</a:t>
             </a:r>
             <a:r>
-              <a:rPr lang="en-US" sz="2400" dirty="0" spc="-15" kern="0">
+              <a:rPr lang="en-US" sz="2100" dirty="0" spc="-18" kern="0">
                 <a:solidFill>
                   <a:srgbClr val="F3EEE3"/>
                 </a:solidFill>
@@ -17972,18 +18445,40 @@
               <a:t> byte</a:t>
             </a:r>
             <a:r>
-              <a:rPr lang="en-US" sz="2400" dirty="0" spc="1" kern="0">
-                <a:solidFill>
-                  <a:srgbClr val="F3EEE3"/>
-                </a:solidFill>
-                <a:latin typeface="Be Vietnam Pro" pitchFamily="34" charset="0"/>
-                <a:ea typeface="Be Vietnam Pro" pitchFamily="34" charset="-122"/>
-                <a:cs typeface="Be Vietnam Pro" pitchFamily="34" charset="-120"/>
-              </a:rPr>
-              <a:t> lớn</a:t>
-            </a:r>
-            <a:r>
-              <a:rPr lang="en-US" sz="2400" dirty="0" spc="-8" kern="0">
+              <a:rPr lang="en-US" sz="2100" dirty="0" spc="-15" kern="0">
+                <a:solidFill>
+                  <a:srgbClr val="F3EEE3"/>
+                </a:solidFill>
+                <a:latin typeface="Be Vietnam Pro" pitchFamily="34" charset="0"/>
+                <a:ea typeface="Be Vietnam Pro" pitchFamily="34" charset="-122"/>
+                <a:cs typeface="Be Vietnam Pro" pitchFamily="34" charset="-120"/>
+              </a:rPr>
+              <a:t> trọng</a:t>
+            </a:r>
+            <a:r>
+              <a:rPr lang="en-US" sz="2100" dirty="0" spc="-10" kern="0">
+                <a:solidFill>
+                  <a:srgbClr val="F3EEE3"/>
+                </a:solidFill>
+                <a:latin typeface="Be Vietnam Pro" pitchFamily="34" charset="0"/>
+                <a:ea typeface="Be Vietnam Pro" pitchFamily="34" charset="-122"/>
+                <a:cs typeface="Be Vietnam Pro" pitchFamily="34" charset="-120"/>
+              </a:rPr>
+              <a:t> số</a:t>
+            </a:r>
+            <a:r>
+              <a:rPr lang="en-US" sz="2100" dirty="0" spc="-2" kern="0">
+                <a:solidFill>
+                  <a:srgbClr val="F3EEE3"/>
+                </a:solidFill>
+                <a:latin typeface="Be Vietnam Pro" pitchFamily="34" charset="0"/>
+                <a:ea typeface="Be Vietnam Pro" pitchFamily="34" charset="-122"/>
+                <a:cs typeface="Be Vietnam Pro" pitchFamily="34" charset="-120"/>
+              </a:rPr>
+              <a:t> cao</a:t>
+            </a:r>
+            <a:r>
+              <a:rPr lang="en-US" sz="2100" dirty="0" spc="-10" kern="0">
                 <a:solidFill>
                   <a:srgbClr val="F3EEE3"/>
                 </a:solidFill>
@@ -17993,19 +18488,19 @@
               </a:rPr>
               <a:t> nhất</a:t>
             </a:r>
-            <a:endParaRPr lang="en-US" sz="2400" dirty="0"/>
-          </a:p>
-          <a:p>
-            <a:pPr algn="l" marL="304800" indent="-217761">
+            <a:endParaRPr lang="en-US" sz="2100" dirty="0"/>
+          </a:p>
+          <a:p>
+            <a:pPr algn="l" marL="266700" indent="-190541">
               <a:lnSpc>
-                <a:spcPts val="3360"/>
+                <a:spcPts val="2940"/>
               </a:lnSpc>
               <a:buSzPct val="100000"/>
               <a:buFont typeface="Arial"/>
               <a:buChar char="•"/>
             </a:pPr>
             <a:r>
-              <a:rPr lang="en-US" sz="2400" dirty="0" spc="-4" kern="0">
+              <a:rPr lang="en-US" sz="2100" dirty="0" spc="-5" kern="0">
                 <a:solidFill>
                   <a:srgbClr val="F3EEE3"/>
                 </a:solidFill>
@@ -18016,7 +18511,7 @@
               <a:t>Little</a:t>
             </a:r>
             <a:r>
-              <a:rPr lang="en-US" sz="2400" dirty="0" spc="0" kern="0">
+              <a:rPr lang="en-US" sz="2100" dirty="0" spc="0" kern="0">
                 <a:solidFill>
                   <a:srgbClr val="F3EEE3"/>
                 </a:solidFill>
@@ -18027,7 +18522,7 @@
               <a:t> endian:</a:t>
             </a:r>
             <a:r>
-              <a:rPr lang="en-US" sz="2400" dirty="0" spc="-15" kern="0">
+              <a:rPr lang="en-US" sz="2100" dirty="0" spc="-19" kern="0">
                 <a:solidFill>
                   <a:srgbClr val="F3EEE3"/>
                 </a:solidFill>
@@ -18038,18 +18533,40 @@
               <a:t> byte</a:t>
             </a:r>
             <a:r>
-              <a:rPr lang="en-US" sz="2400" dirty="0" spc="0" kern="0">
-                <a:solidFill>
-                  <a:srgbClr val="F3EEE3"/>
-                </a:solidFill>
-                <a:latin typeface="Be Vietnam Pro" pitchFamily="34" charset="0"/>
-                <a:ea typeface="Be Vietnam Pro" pitchFamily="34" charset="-122"/>
-                <a:cs typeface="Be Vietnam Pro" pitchFamily="34" charset="-120"/>
-              </a:rPr>
-              <a:t> nhỏ</a:t>
-            </a:r>
-            <a:r>
-              <a:rPr lang="en-US" sz="2400" dirty="0" spc="-8" kern="0">
+              <a:rPr lang="en-US" sz="2100" dirty="0" spc="-15" kern="0">
+                <a:solidFill>
+                  <a:srgbClr val="F3EEE3"/>
+                </a:solidFill>
+                <a:latin typeface="Be Vietnam Pro" pitchFamily="34" charset="0"/>
+                <a:ea typeface="Be Vietnam Pro" pitchFamily="34" charset="-122"/>
+                <a:cs typeface="Be Vietnam Pro" pitchFamily="34" charset="-120"/>
+              </a:rPr>
+              <a:t> trọng</a:t>
+            </a:r>
+            <a:r>
+              <a:rPr lang="en-US" sz="2100" dirty="0" spc="-10" kern="0">
+                <a:solidFill>
+                  <a:srgbClr val="F3EEE3"/>
+                </a:solidFill>
+                <a:latin typeface="Be Vietnam Pro" pitchFamily="34" charset="0"/>
+                <a:ea typeface="Be Vietnam Pro" pitchFamily="34" charset="-122"/>
+                <a:cs typeface="Be Vietnam Pro" pitchFamily="34" charset="-120"/>
+              </a:rPr>
+              <a:t> số</a:t>
+            </a:r>
+            <a:r>
+              <a:rPr lang="en-US" sz="2100" dirty="0" spc="-3" kern="0">
+                <a:solidFill>
+                  <a:srgbClr val="F3EEE3"/>
+                </a:solidFill>
+                <a:latin typeface="Be Vietnam Pro" pitchFamily="34" charset="0"/>
+                <a:ea typeface="Be Vietnam Pro" pitchFamily="34" charset="-122"/>
+                <a:cs typeface="Be Vietnam Pro" pitchFamily="34" charset="-120"/>
+              </a:rPr>
+              <a:t> thấp</a:t>
+            </a:r>
+            <a:r>
+              <a:rPr lang="en-US" sz="2100" dirty="0" spc="-10" kern="0">
                 <a:solidFill>
                   <a:srgbClr val="F3EEE3"/>
                 </a:solidFill>
@@ -18059,7 +18576,7 @@
               </a:rPr>
               <a:t> nhất</a:t>
             </a:r>
-            <a:endParaRPr lang="en-US" sz="2400" dirty="0"/>
+            <a:endParaRPr lang="en-US" sz="2100" dirty="0"/>
           </a:p>
         </p:txBody>
       </p:sp>

</xml_diff>